<commit_message>
Preserve manual polar data label probes
</commit_message>
<xml_diff>
--- a/tests/Lokad.OoxPdf.Tests/Cases/pptx-ladder-11-chart-pie-data-label-leader-lines-probe.pptx
+++ b/tests/Lokad.OoxPdf.Tests/Cases/pptx-ladder-11-chart-pie-data-label-leader-lines-probe.pptx
@@ -150,7 +150,7 @@
             </c:spPr>
             <c:extLst>
               <c:ext xmlns:c16="http://schemas.microsoft.com/office/drawing/2014/chart" uri="{C3380CC4-5D6E-409C-BE32-E72D297353CC}">
-                <c16:uniqueId val="{00000001-E05E-44DE-884F-55AD7F02845B}"/>
+                <c16:uniqueId val="{00000001-595E-40CF-AEDC-215BCE2ACEE7}"/>
               </c:ext>
             </c:extLst>
           </c:dPt>
@@ -164,7 +164,7 @@
             </c:spPr>
             <c:extLst>
               <c:ext xmlns:c16="http://schemas.microsoft.com/office/drawing/2014/chart" uri="{C3380CC4-5D6E-409C-BE32-E72D297353CC}">
-                <c16:uniqueId val="{00000002-E05E-44DE-884F-55AD7F02845B}"/>
+                <c16:uniqueId val="{00000002-595E-40CF-AEDC-215BCE2ACEE7}"/>
               </c:ext>
             </c:extLst>
           </c:dPt>
@@ -178,7 +178,7 @@
             </c:spPr>
             <c:extLst>
               <c:ext xmlns:c16="http://schemas.microsoft.com/office/drawing/2014/chart" uri="{C3380CC4-5D6E-409C-BE32-E72D297353CC}">
-                <c16:uniqueId val="{00000003-E05E-44DE-884F-55AD7F02845B}"/>
+                <c16:uniqueId val="{00000003-595E-40CF-AEDC-215BCE2ACEE7}"/>
               </c:ext>
             </c:extLst>
           </c:dPt>
@@ -192,11 +192,107 @@
             </c:spPr>
             <c:extLst>
               <c:ext xmlns:c16="http://schemas.microsoft.com/office/drawing/2014/chart" uri="{C3380CC4-5D6E-409C-BE32-E72D297353CC}">
-                <c16:uniqueId val="{00000004-E05E-44DE-884F-55AD7F02845B}"/>
+                <c16:uniqueId val="{00000004-595E-40CF-AEDC-215BCE2ACEE7}"/>
               </c:ext>
             </c:extLst>
           </c:dPt>
           <c:dLbls>
+            <c:dLbl>
+              <c:idx val="0"/>
+              <c:layout>
+                <c:manualLayout>
+                  <c:x val="-0.67258721566054247"/>
+                  <c:y val="-0.32275371828521437"/>
+                </c:manualLayout>
+              </c:layout>
+              <c:dLblPos val="bestFit"/>
+              <c:showLegendKey val="1"/>
+              <c:showVal val="0"/>
+              <c:showCatName val="1"/>
+              <c:showSerName val="0"/>
+              <c:showPercent val="1"/>
+              <c:showBubbleSize val="0"/>
+              <c:separator>
+</c:separator>
+              <c:extLst>
+                <c:ext xmlns:c15="http://schemas.microsoft.com/office/drawing/2012/chart" uri="{CE6537A1-D6FC-4f65-9D91-7224C49458BB}"/>
+                <c:ext xmlns:c16="http://schemas.microsoft.com/office/drawing/2014/chart" uri="{C3380CC4-5D6E-409C-BE32-E72D297353CC}">
+                  <c16:uniqueId val="{00000001-595E-40CF-AEDC-215BCE2ACEE7}"/>
+                </c:ext>
+              </c:extLst>
+            </c:dLbl>
+            <c:dLbl>
+              <c:idx val="1"/>
+              <c:layout>
+                <c:manualLayout>
+                  <c:x val="0.59602321194225727"/>
+                  <c:y val="-0.43125437445319337"/>
+                </c:manualLayout>
+              </c:layout>
+              <c:dLblPos val="bestFit"/>
+              <c:showLegendKey val="1"/>
+              <c:showVal val="0"/>
+              <c:showCatName val="1"/>
+              <c:showSerName val="0"/>
+              <c:showPercent val="1"/>
+              <c:showBubbleSize val="0"/>
+              <c:separator>
+</c:separator>
+              <c:extLst>
+                <c:ext xmlns:c15="http://schemas.microsoft.com/office/drawing/2012/chart" uri="{CE6537A1-D6FC-4f65-9D91-7224C49458BB}"/>
+                <c:ext xmlns:c16="http://schemas.microsoft.com/office/drawing/2014/chart" uri="{C3380CC4-5D6E-409C-BE32-E72D297353CC}">
+                  <c16:uniqueId val="{00000002-595E-40CF-AEDC-215BCE2ACEE7}"/>
+                </c:ext>
+              </c:extLst>
+            </c:dLbl>
+            <c:dLbl>
+              <c:idx val="2"/>
+              <c:layout>
+                <c:manualLayout>
+                  <c:x val="7.7810996281714784E-2"/>
+                  <c:y val="0.2432843030037912"/>
+                </c:manualLayout>
+              </c:layout>
+              <c:dLblPos val="bestFit"/>
+              <c:showLegendKey val="1"/>
+              <c:showVal val="0"/>
+              <c:showCatName val="1"/>
+              <c:showSerName val="0"/>
+              <c:showPercent val="1"/>
+              <c:showBubbleSize val="0"/>
+              <c:separator>
+</c:separator>
+              <c:extLst>
+                <c:ext xmlns:c15="http://schemas.microsoft.com/office/drawing/2012/chart" uri="{CE6537A1-D6FC-4f65-9D91-7224C49458BB}"/>
+                <c:ext xmlns:c16="http://schemas.microsoft.com/office/drawing/2014/chart" uri="{C3380CC4-5D6E-409C-BE32-E72D297353CC}">
+                  <c16:uniqueId val="{00000003-595E-40CF-AEDC-215BCE2ACEE7}"/>
+                </c:ext>
+              </c:extLst>
+            </c:dLbl>
+            <c:dLbl>
+              <c:idx val="3"/>
+              <c:layout>
+                <c:manualLayout>
+                  <c:x val="3.0550634295713038E-2"/>
+                  <c:y val="0.87037037037037035"/>
+                </c:manualLayout>
+              </c:layout>
+              <c:dLblPos val="bestFit"/>
+              <c:showLegendKey val="1"/>
+              <c:showVal val="0"/>
+              <c:showCatName val="1"/>
+              <c:showSerName val="0"/>
+              <c:showPercent val="1"/>
+              <c:showBubbleSize val="0"/>
+              <c:separator>
+</c:separator>
+              <c:extLst>
+                <c:ext xmlns:c15="http://schemas.microsoft.com/office/drawing/2012/chart" uri="{CE6537A1-D6FC-4f65-9D91-7224C49458BB}"/>
+                <c:ext xmlns:c16="http://schemas.microsoft.com/office/drawing/2014/chart" uri="{C3380CC4-5D6E-409C-BE32-E72D297353CC}">
+                  <c16:uniqueId val="{00000004-595E-40CF-AEDC-215BCE2ACEE7}"/>
+                </c:ext>
+              </c:extLst>
+            </c:dLbl>
             <c:spPr>
               <a:noFill/>
               <a:ln>
@@ -270,7 +366,7 @@
           </c:val>
           <c:extLst>
             <c:ext xmlns:c16="http://schemas.microsoft.com/office/drawing/2014/chart" uri="{C3380CC4-5D6E-409C-BE32-E72D297353CC}">
-              <c16:uniqueId val="{00000000-E05E-44DE-884F-55AD7F02845B}"/>
+              <c16:uniqueId val="{00000000-595E-40CF-AEDC-215BCE2ACEE7}"/>
             </c:ext>
           </c:extLst>
         </c:ser>
@@ -335,7 +431,7 @@
           <p:cNvPr id="2" name="Title 1">
             <a:extLst>
               <a:ext uri="{FF2B5EF4-FFF2-40B4-BE49-F238E27FC236}">
-                <a16:creationId xmlns:a16="http://schemas.microsoft.com/office/drawing/2014/main" id="{230F9D0A-3ABB-BD91-E103-A6B0F5965101}"/>
+                <a16:creationId xmlns:a16="http://schemas.microsoft.com/office/drawing/2014/main" id="{162AE65C-061F-1EC8-FE04-589A3F32DADD}"/>
               </a:ext>
             </a:extLst>
           </p:cNvPr>
@@ -372,7 +468,7 @@
           <p:cNvPr id="3" name="Subtitle 2">
             <a:extLst>
               <a:ext uri="{FF2B5EF4-FFF2-40B4-BE49-F238E27FC236}">
-                <a16:creationId xmlns:a16="http://schemas.microsoft.com/office/drawing/2014/main" id="{76A73EC5-C8D8-AF60-1479-FFC548E50F14}"/>
+                <a16:creationId xmlns:a16="http://schemas.microsoft.com/office/drawing/2014/main" id="{A981B51A-EEB0-0631-11AE-D189C91B7BE0}"/>
               </a:ext>
             </a:extLst>
           </p:cNvPr>
@@ -442,7 +538,7 @@
           <p:cNvPr id="4" name="Date Placeholder 3">
             <a:extLst>
               <a:ext uri="{FF2B5EF4-FFF2-40B4-BE49-F238E27FC236}">
-                <a16:creationId xmlns:a16="http://schemas.microsoft.com/office/drawing/2014/main" id="{E0311985-85E9-1536-788A-958C47AE177C}"/>
+                <a16:creationId xmlns:a16="http://schemas.microsoft.com/office/drawing/2014/main" id="{6905DAE0-DDB2-9CD8-2EFB-3DE67FFB1D1C}"/>
               </a:ext>
             </a:extLst>
           </p:cNvPr>
@@ -458,7 +554,7 @@
           <a:bodyPr/>
           <a:lstStyle/>
           <a:p>
-            <a:fld id="{7C972402-98C4-49BE-9E44-3AE0CE18D547}" type="datetimeFigureOut">
+            <a:fld id="{3B04DCD2-51FF-4424-A8D0-554917C1B566}" type="datetimeFigureOut">
               <a:rPr lang="en-US" smtClean="0"/>
               <a:t>5/27/2026</a:t>
             </a:fld>
@@ -471,7 +567,7 @@
           <p:cNvPr id="5" name="Footer Placeholder 4">
             <a:extLst>
               <a:ext uri="{FF2B5EF4-FFF2-40B4-BE49-F238E27FC236}">
-                <a16:creationId xmlns:a16="http://schemas.microsoft.com/office/drawing/2014/main" id="{9D0134E8-D6AA-46C6-099D-E92318819E5E}"/>
+                <a16:creationId xmlns:a16="http://schemas.microsoft.com/office/drawing/2014/main" id="{1E852E90-7800-C5B0-A50E-DD16FDEF2369}"/>
               </a:ext>
             </a:extLst>
           </p:cNvPr>
@@ -496,7 +592,7 @@
           <p:cNvPr id="6" name="Slide Number Placeholder 5">
             <a:extLst>
               <a:ext uri="{FF2B5EF4-FFF2-40B4-BE49-F238E27FC236}">
-                <a16:creationId xmlns:a16="http://schemas.microsoft.com/office/drawing/2014/main" id="{8C76893D-1B80-CE8B-1C7D-96D45A8BB1C7}"/>
+                <a16:creationId xmlns:a16="http://schemas.microsoft.com/office/drawing/2014/main" id="{4B623324-B93A-9661-0F09-1923CC1F6DD7}"/>
               </a:ext>
             </a:extLst>
           </p:cNvPr>
@@ -512,7 +608,7 @@
           <a:bodyPr/>
           <a:lstStyle/>
           <a:p>
-            <a:fld id="{54FF740A-2CFB-4C12-9B69-14E08326A350}" type="slidenum">
+            <a:fld id="{AB36B74C-88B0-43C8-957A-2BB332CCF888}" type="slidenum">
               <a:rPr lang="en-US" smtClean="0"/>
               <a:t>‹#›</a:t>
             </a:fld>
@@ -523,7 +619,7 @@
     </p:spTree>
     <p:extLst>
       <p:ext uri="{BB962C8B-B14F-4D97-AF65-F5344CB8AC3E}">
-        <p14:creationId xmlns:p14="http://schemas.microsoft.com/office/powerpoint/2010/main" val="333975498"/>
+        <p14:creationId xmlns:p14="http://schemas.microsoft.com/office/powerpoint/2010/main" val="2606980311"/>
       </p:ext>
     </p:extLst>
   </p:cSld>
@@ -555,7 +651,7 @@
           <p:cNvPr id="2" name="Title 1">
             <a:extLst>
               <a:ext uri="{FF2B5EF4-FFF2-40B4-BE49-F238E27FC236}">
-                <a16:creationId xmlns:a16="http://schemas.microsoft.com/office/drawing/2014/main" id="{9FEFC4C5-3214-FD4E-97B3-78727FD55E6E}"/>
+                <a16:creationId xmlns:a16="http://schemas.microsoft.com/office/drawing/2014/main" id="{0A313C5C-DAFC-AFDB-660E-ABF2FF666221}"/>
               </a:ext>
             </a:extLst>
           </p:cNvPr>
@@ -583,7 +679,7 @@
           <p:cNvPr id="3" name="Vertical Text Placeholder 2">
             <a:extLst>
               <a:ext uri="{FF2B5EF4-FFF2-40B4-BE49-F238E27FC236}">
-                <a16:creationId xmlns:a16="http://schemas.microsoft.com/office/drawing/2014/main" id="{E6D72DD5-6EC7-02D0-4C39-9E57F7B73EF3}"/>
+                <a16:creationId xmlns:a16="http://schemas.microsoft.com/office/drawing/2014/main" id="{A3BFDB55-799D-0516-A2CE-CFEB682B3406}"/>
               </a:ext>
             </a:extLst>
           </p:cNvPr>
@@ -640,7 +736,7 @@
           <p:cNvPr id="4" name="Date Placeholder 3">
             <a:extLst>
               <a:ext uri="{FF2B5EF4-FFF2-40B4-BE49-F238E27FC236}">
-                <a16:creationId xmlns:a16="http://schemas.microsoft.com/office/drawing/2014/main" id="{119137BE-CECF-92B8-7057-68A371324E2D}"/>
+                <a16:creationId xmlns:a16="http://schemas.microsoft.com/office/drawing/2014/main" id="{012FF424-C4EB-B3EE-5CE3-7E363A94B4DA}"/>
               </a:ext>
             </a:extLst>
           </p:cNvPr>
@@ -656,7 +752,7 @@
           <a:bodyPr/>
           <a:lstStyle/>
           <a:p>
-            <a:fld id="{7C972402-98C4-49BE-9E44-3AE0CE18D547}" type="datetimeFigureOut">
+            <a:fld id="{3B04DCD2-51FF-4424-A8D0-554917C1B566}" type="datetimeFigureOut">
               <a:rPr lang="en-US" smtClean="0"/>
               <a:t>5/27/2026</a:t>
             </a:fld>
@@ -669,7 +765,7 @@
           <p:cNvPr id="5" name="Footer Placeholder 4">
             <a:extLst>
               <a:ext uri="{FF2B5EF4-FFF2-40B4-BE49-F238E27FC236}">
-                <a16:creationId xmlns:a16="http://schemas.microsoft.com/office/drawing/2014/main" id="{4E8530BE-5C5A-3A22-B0FA-9225EF8BF862}"/>
+                <a16:creationId xmlns:a16="http://schemas.microsoft.com/office/drawing/2014/main" id="{BBA42764-DA31-6A79-AAF3-EFA22C1F3BEA}"/>
               </a:ext>
             </a:extLst>
           </p:cNvPr>
@@ -694,7 +790,7 @@
           <p:cNvPr id="6" name="Slide Number Placeholder 5">
             <a:extLst>
               <a:ext uri="{FF2B5EF4-FFF2-40B4-BE49-F238E27FC236}">
-                <a16:creationId xmlns:a16="http://schemas.microsoft.com/office/drawing/2014/main" id="{25986D04-01C1-E197-C96C-676C0AB2CC8C}"/>
+                <a16:creationId xmlns:a16="http://schemas.microsoft.com/office/drawing/2014/main" id="{A046046A-65CC-0BE0-7350-277F5FD15206}"/>
               </a:ext>
             </a:extLst>
           </p:cNvPr>
@@ -710,7 +806,7 @@
           <a:bodyPr/>
           <a:lstStyle/>
           <a:p>
-            <a:fld id="{54FF740A-2CFB-4C12-9B69-14E08326A350}" type="slidenum">
+            <a:fld id="{AB36B74C-88B0-43C8-957A-2BB332CCF888}" type="slidenum">
               <a:rPr lang="en-US" smtClean="0"/>
               <a:t>‹#›</a:t>
             </a:fld>
@@ -721,7 +817,7 @@
     </p:spTree>
     <p:extLst>
       <p:ext uri="{BB962C8B-B14F-4D97-AF65-F5344CB8AC3E}">
-        <p14:creationId xmlns:p14="http://schemas.microsoft.com/office/powerpoint/2010/main" val="2605280611"/>
+        <p14:creationId xmlns:p14="http://schemas.microsoft.com/office/powerpoint/2010/main" val="3157435993"/>
       </p:ext>
     </p:extLst>
   </p:cSld>
@@ -753,7 +849,7 @@
           <p:cNvPr id="2" name="Vertical Title 1">
             <a:extLst>
               <a:ext uri="{FF2B5EF4-FFF2-40B4-BE49-F238E27FC236}">
-                <a16:creationId xmlns:a16="http://schemas.microsoft.com/office/drawing/2014/main" id="{6A1E3D81-E9FF-3EC7-9120-3F373E9CBBE1}"/>
+                <a16:creationId xmlns:a16="http://schemas.microsoft.com/office/drawing/2014/main" id="{744F117A-C5E3-B89C-F131-06B9C9F7CE63}"/>
               </a:ext>
             </a:extLst>
           </p:cNvPr>
@@ -786,7 +882,7 @@
           <p:cNvPr id="3" name="Vertical Text Placeholder 2">
             <a:extLst>
               <a:ext uri="{FF2B5EF4-FFF2-40B4-BE49-F238E27FC236}">
-                <a16:creationId xmlns:a16="http://schemas.microsoft.com/office/drawing/2014/main" id="{BA495748-90F1-6601-E207-3B2E27EB8D4D}"/>
+                <a16:creationId xmlns:a16="http://schemas.microsoft.com/office/drawing/2014/main" id="{F8AE3E4A-625C-1056-7769-ECA765135364}"/>
               </a:ext>
             </a:extLst>
           </p:cNvPr>
@@ -848,7 +944,7 @@
           <p:cNvPr id="4" name="Date Placeholder 3">
             <a:extLst>
               <a:ext uri="{FF2B5EF4-FFF2-40B4-BE49-F238E27FC236}">
-                <a16:creationId xmlns:a16="http://schemas.microsoft.com/office/drawing/2014/main" id="{90290261-8548-E60C-D2A8-398C7CA68750}"/>
+                <a16:creationId xmlns:a16="http://schemas.microsoft.com/office/drawing/2014/main" id="{4E0B8359-0387-409A-B197-94CCC4B527CB}"/>
               </a:ext>
             </a:extLst>
           </p:cNvPr>
@@ -864,7 +960,7 @@
           <a:bodyPr/>
           <a:lstStyle/>
           <a:p>
-            <a:fld id="{7C972402-98C4-49BE-9E44-3AE0CE18D547}" type="datetimeFigureOut">
+            <a:fld id="{3B04DCD2-51FF-4424-A8D0-554917C1B566}" type="datetimeFigureOut">
               <a:rPr lang="en-US" smtClean="0"/>
               <a:t>5/27/2026</a:t>
             </a:fld>
@@ -877,7 +973,7 @@
           <p:cNvPr id="5" name="Footer Placeholder 4">
             <a:extLst>
               <a:ext uri="{FF2B5EF4-FFF2-40B4-BE49-F238E27FC236}">
-                <a16:creationId xmlns:a16="http://schemas.microsoft.com/office/drawing/2014/main" id="{790A46D6-F379-E973-512C-C8E6DCC981B8}"/>
+                <a16:creationId xmlns:a16="http://schemas.microsoft.com/office/drawing/2014/main" id="{3E3CEC6D-1AE8-4F08-3208-73B49ACB58E7}"/>
               </a:ext>
             </a:extLst>
           </p:cNvPr>
@@ -902,7 +998,7 @@
           <p:cNvPr id="6" name="Slide Number Placeholder 5">
             <a:extLst>
               <a:ext uri="{FF2B5EF4-FFF2-40B4-BE49-F238E27FC236}">
-                <a16:creationId xmlns:a16="http://schemas.microsoft.com/office/drawing/2014/main" id="{33971DF8-BBB7-EE47-E677-55B6C9C9CF7F}"/>
+                <a16:creationId xmlns:a16="http://schemas.microsoft.com/office/drawing/2014/main" id="{89DE7454-6E70-B5F4-5EAF-CAE6A7D06F68}"/>
               </a:ext>
             </a:extLst>
           </p:cNvPr>
@@ -918,7 +1014,7 @@
           <a:bodyPr/>
           <a:lstStyle/>
           <a:p>
-            <a:fld id="{54FF740A-2CFB-4C12-9B69-14E08326A350}" type="slidenum">
+            <a:fld id="{AB36B74C-88B0-43C8-957A-2BB332CCF888}" type="slidenum">
               <a:rPr lang="en-US" smtClean="0"/>
               <a:t>‹#›</a:t>
             </a:fld>
@@ -929,7 +1025,7 @@
     </p:spTree>
     <p:extLst>
       <p:ext uri="{BB962C8B-B14F-4D97-AF65-F5344CB8AC3E}">
-        <p14:creationId xmlns:p14="http://schemas.microsoft.com/office/powerpoint/2010/main" val="3362134760"/>
+        <p14:creationId xmlns:p14="http://schemas.microsoft.com/office/powerpoint/2010/main" val="619837183"/>
       </p:ext>
     </p:extLst>
   </p:cSld>
@@ -961,7 +1057,7 @@
           <p:cNvPr id="2" name="Title 1">
             <a:extLst>
               <a:ext uri="{FF2B5EF4-FFF2-40B4-BE49-F238E27FC236}">
-                <a16:creationId xmlns:a16="http://schemas.microsoft.com/office/drawing/2014/main" id="{A2D86C36-CD3D-28F6-A070-5F89F70EC4A5}"/>
+                <a16:creationId xmlns:a16="http://schemas.microsoft.com/office/drawing/2014/main" id="{FABCE650-2197-00A6-469F-66423AA4010A}"/>
               </a:ext>
             </a:extLst>
           </p:cNvPr>
@@ -989,7 +1085,7 @@
           <p:cNvPr id="3" name="Content Placeholder 2">
             <a:extLst>
               <a:ext uri="{FF2B5EF4-FFF2-40B4-BE49-F238E27FC236}">
-                <a16:creationId xmlns:a16="http://schemas.microsoft.com/office/drawing/2014/main" id="{C2A3B5AE-A0C5-AD9F-42E9-7CBAAA868D2A}"/>
+                <a16:creationId xmlns:a16="http://schemas.microsoft.com/office/drawing/2014/main" id="{F2109BBB-887F-09FC-A180-0A009289AED0}"/>
               </a:ext>
             </a:extLst>
           </p:cNvPr>
@@ -1046,7 +1142,7 @@
           <p:cNvPr id="4" name="Date Placeholder 3">
             <a:extLst>
               <a:ext uri="{FF2B5EF4-FFF2-40B4-BE49-F238E27FC236}">
-                <a16:creationId xmlns:a16="http://schemas.microsoft.com/office/drawing/2014/main" id="{84BCF139-590E-3CF3-C87C-F99C3335D67C}"/>
+                <a16:creationId xmlns:a16="http://schemas.microsoft.com/office/drawing/2014/main" id="{81B47D16-7C35-702B-FCCC-D590A3AFAABD}"/>
               </a:ext>
             </a:extLst>
           </p:cNvPr>
@@ -1062,7 +1158,7 @@
           <a:bodyPr/>
           <a:lstStyle/>
           <a:p>
-            <a:fld id="{7C972402-98C4-49BE-9E44-3AE0CE18D547}" type="datetimeFigureOut">
+            <a:fld id="{3B04DCD2-51FF-4424-A8D0-554917C1B566}" type="datetimeFigureOut">
               <a:rPr lang="en-US" smtClean="0"/>
               <a:t>5/27/2026</a:t>
             </a:fld>
@@ -1075,7 +1171,7 @@
           <p:cNvPr id="5" name="Footer Placeholder 4">
             <a:extLst>
               <a:ext uri="{FF2B5EF4-FFF2-40B4-BE49-F238E27FC236}">
-                <a16:creationId xmlns:a16="http://schemas.microsoft.com/office/drawing/2014/main" id="{18E7E753-3C77-F3FC-6AC2-64FF3EFCA28B}"/>
+                <a16:creationId xmlns:a16="http://schemas.microsoft.com/office/drawing/2014/main" id="{FBF3B851-5D3F-A2CC-5B49-6C9107334BDC}"/>
               </a:ext>
             </a:extLst>
           </p:cNvPr>
@@ -1100,7 +1196,7 @@
           <p:cNvPr id="6" name="Slide Number Placeholder 5">
             <a:extLst>
               <a:ext uri="{FF2B5EF4-FFF2-40B4-BE49-F238E27FC236}">
-                <a16:creationId xmlns:a16="http://schemas.microsoft.com/office/drawing/2014/main" id="{7514ED23-7361-C3E4-2929-EC14CEA60B44}"/>
+                <a16:creationId xmlns:a16="http://schemas.microsoft.com/office/drawing/2014/main" id="{1476D9C1-BA80-FC2F-EDCB-52C500DAD901}"/>
               </a:ext>
             </a:extLst>
           </p:cNvPr>
@@ -1116,7 +1212,7 @@
           <a:bodyPr/>
           <a:lstStyle/>
           <a:p>
-            <a:fld id="{54FF740A-2CFB-4C12-9B69-14E08326A350}" type="slidenum">
+            <a:fld id="{AB36B74C-88B0-43C8-957A-2BB332CCF888}" type="slidenum">
               <a:rPr lang="en-US" smtClean="0"/>
               <a:t>‹#›</a:t>
             </a:fld>
@@ -1127,7 +1223,7 @@
     </p:spTree>
     <p:extLst>
       <p:ext uri="{BB962C8B-B14F-4D97-AF65-F5344CB8AC3E}">
-        <p14:creationId xmlns:p14="http://schemas.microsoft.com/office/powerpoint/2010/main" val="3212323042"/>
+        <p14:creationId xmlns:p14="http://schemas.microsoft.com/office/powerpoint/2010/main" val="1385687580"/>
       </p:ext>
     </p:extLst>
   </p:cSld>
@@ -1159,7 +1255,7 @@
           <p:cNvPr id="2" name="Title 1">
             <a:extLst>
               <a:ext uri="{FF2B5EF4-FFF2-40B4-BE49-F238E27FC236}">
-                <a16:creationId xmlns:a16="http://schemas.microsoft.com/office/drawing/2014/main" id="{9D80C72A-6C28-3DE2-9153-5A77C3CB70B4}"/>
+                <a16:creationId xmlns:a16="http://schemas.microsoft.com/office/drawing/2014/main" id="{051AC5FA-8FE9-0171-4C7F-8430BCB7C0DE}"/>
               </a:ext>
             </a:extLst>
           </p:cNvPr>
@@ -1196,7 +1292,7 @@
           <p:cNvPr id="3" name="Text Placeholder 2">
             <a:extLst>
               <a:ext uri="{FF2B5EF4-FFF2-40B4-BE49-F238E27FC236}">
-                <a16:creationId xmlns:a16="http://schemas.microsoft.com/office/drawing/2014/main" id="{045A66C9-0450-AB9A-00A1-12561EA5C573}"/>
+                <a16:creationId xmlns:a16="http://schemas.microsoft.com/office/drawing/2014/main" id="{792B8CAE-272D-6BE6-F4A6-DD4D19FD044E}"/>
               </a:ext>
             </a:extLst>
           </p:cNvPr>
@@ -1321,7 +1417,7 @@
           <p:cNvPr id="4" name="Date Placeholder 3">
             <a:extLst>
               <a:ext uri="{FF2B5EF4-FFF2-40B4-BE49-F238E27FC236}">
-                <a16:creationId xmlns:a16="http://schemas.microsoft.com/office/drawing/2014/main" id="{0C8FB3DE-790F-F7CA-5FB9-DCA9A22976A8}"/>
+                <a16:creationId xmlns:a16="http://schemas.microsoft.com/office/drawing/2014/main" id="{7CA817AF-B8A6-ABDE-812F-26087D92649B}"/>
               </a:ext>
             </a:extLst>
           </p:cNvPr>
@@ -1337,7 +1433,7 @@
           <a:bodyPr/>
           <a:lstStyle/>
           <a:p>
-            <a:fld id="{7C972402-98C4-49BE-9E44-3AE0CE18D547}" type="datetimeFigureOut">
+            <a:fld id="{3B04DCD2-51FF-4424-A8D0-554917C1B566}" type="datetimeFigureOut">
               <a:rPr lang="en-US" smtClean="0"/>
               <a:t>5/27/2026</a:t>
             </a:fld>
@@ -1350,7 +1446,7 @@
           <p:cNvPr id="5" name="Footer Placeholder 4">
             <a:extLst>
               <a:ext uri="{FF2B5EF4-FFF2-40B4-BE49-F238E27FC236}">
-                <a16:creationId xmlns:a16="http://schemas.microsoft.com/office/drawing/2014/main" id="{439CEB4C-97DE-1CF3-3301-2E33DCCBCB50}"/>
+                <a16:creationId xmlns:a16="http://schemas.microsoft.com/office/drawing/2014/main" id="{3CD163E1-7AF5-961D-E33D-569DB656556E}"/>
               </a:ext>
             </a:extLst>
           </p:cNvPr>
@@ -1375,7 +1471,7 @@
           <p:cNvPr id="6" name="Slide Number Placeholder 5">
             <a:extLst>
               <a:ext uri="{FF2B5EF4-FFF2-40B4-BE49-F238E27FC236}">
-                <a16:creationId xmlns:a16="http://schemas.microsoft.com/office/drawing/2014/main" id="{D3D245EA-8D7B-73CF-AEF9-ACDA5F6BA057}"/>
+                <a16:creationId xmlns:a16="http://schemas.microsoft.com/office/drawing/2014/main" id="{D79B04C5-4BED-49AA-5C33-7D98355AD485}"/>
               </a:ext>
             </a:extLst>
           </p:cNvPr>
@@ -1391,7 +1487,7 @@
           <a:bodyPr/>
           <a:lstStyle/>
           <a:p>
-            <a:fld id="{54FF740A-2CFB-4C12-9B69-14E08326A350}" type="slidenum">
+            <a:fld id="{AB36B74C-88B0-43C8-957A-2BB332CCF888}" type="slidenum">
               <a:rPr lang="en-US" smtClean="0"/>
               <a:t>‹#›</a:t>
             </a:fld>
@@ -1402,7 +1498,7 @@
     </p:spTree>
     <p:extLst>
       <p:ext uri="{BB962C8B-B14F-4D97-AF65-F5344CB8AC3E}">
-        <p14:creationId xmlns:p14="http://schemas.microsoft.com/office/powerpoint/2010/main" val="1601715507"/>
+        <p14:creationId xmlns:p14="http://schemas.microsoft.com/office/powerpoint/2010/main" val="2254276119"/>
       </p:ext>
     </p:extLst>
   </p:cSld>
@@ -1434,7 +1530,7 @@
           <p:cNvPr id="2" name="Title 1">
             <a:extLst>
               <a:ext uri="{FF2B5EF4-FFF2-40B4-BE49-F238E27FC236}">
-                <a16:creationId xmlns:a16="http://schemas.microsoft.com/office/drawing/2014/main" id="{8978E3A6-D82D-89BB-35AA-5DF10C1639D3}"/>
+                <a16:creationId xmlns:a16="http://schemas.microsoft.com/office/drawing/2014/main" id="{265D2CA4-A2FC-FE30-453B-24B32C27EC2C}"/>
               </a:ext>
             </a:extLst>
           </p:cNvPr>
@@ -1462,7 +1558,7 @@
           <p:cNvPr id="3" name="Content Placeholder 2">
             <a:extLst>
               <a:ext uri="{FF2B5EF4-FFF2-40B4-BE49-F238E27FC236}">
-                <a16:creationId xmlns:a16="http://schemas.microsoft.com/office/drawing/2014/main" id="{EA76167E-7F15-8DD1-29B8-186D2BB856F8}"/>
+                <a16:creationId xmlns:a16="http://schemas.microsoft.com/office/drawing/2014/main" id="{18FB3DAF-5148-3D4E-0810-50B862A1CF3D}"/>
               </a:ext>
             </a:extLst>
           </p:cNvPr>
@@ -1524,7 +1620,7 @@
           <p:cNvPr id="4" name="Content Placeholder 3">
             <a:extLst>
               <a:ext uri="{FF2B5EF4-FFF2-40B4-BE49-F238E27FC236}">
-                <a16:creationId xmlns:a16="http://schemas.microsoft.com/office/drawing/2014/main" id="{CCC36015-3C1B-62B1-E4EA-F784C2390CD0}"/>
+                <a16:creationId xmlns:a16="http://schemas.microsoft.com/office/drawing/2014/main" id="{05F12D36-7E02-3ABA-44D2-32E44FD18C7D}"/>
               </a:ext>
             </a:extLst>
           </p:cNvPr>
@@ -1586,7 +1682,7 @@
           <p:cNvPr id="5" name="Date Placeholder 4">
             <a:extLst>
               <a:ext uri="{FF2B5EF4-FFF2-40B4-BE49-F238E27FC236}">
-                <a16:creationId xmlns:a16="http://schemas.microsoft.com/office/drawing/2014/main" id="{4081632B-CA6B-F18B-732E-E7C127625DE8}"/>
+                <a16:creationId xmlns:a16="http://schemas.microsoft.com/office/drawing/2014/main" id="{54E83DB8-9399-A200-155E-FAE1C72D23F3}"/>
               </a:ext>
             </a:extLst>
           </p:cNvPr>
@@ -1602,7 +1698,7 @@
           <a:bodyPr/>
           <a:lstStyle/>
           <a:p>
-            <a:fld id="{7C972402-98C4-49BE-9E44-3AE0CE18D547}" type="datetimeFigureOut">
+            <a:fld id="{3B04DCD2-51FF-4424-A8D0-554917C1B566}" type="datetimeFigureOut">
               <a:rPr lang="en-US" smtClean="0"/>
               <a:t>5/27/2026</a:t>
             </a:fld>
@@ -1615,7 +1711,7 @@
           <p:cNvPr id="6" name="Footer Placeholder 5">
             <a:extLst>
               <a:ext uri="{FF2B5EF4-FFF2-40B4-BE49-F238E27FC236}">
-                <a16:creationId xmlns:a16="http://schemas.microsoft.com/office/drawing/2014/main" id="{70F97B7D-983F-96D4-D924-E733DFD1F8C6}"/>
+                <a16:creationId xmlns:a16="http://schemas.microsoft.com/office/drawing/2014/main" id="{D3C66257-9990-DEC4-E54E-4CDE3C90DEDB}"/>
               </a:ext>
             </a:extLst>
           </p:cNvPr>
@@ -1640,7 +1736,7 @@
           <p:cNvPr id="7" name="Slide Number Placeholder 6">
             <a:extLst>
               <a:ext uri="{FF2B5EF4-FFF2-40B4-BE49-F238E27FC236}">
-                <a16:creationId xmlns:a16="http://schemas.microsoft.com/office/drawing/2014/main" id="{74E54C26-E9B2-A9F4-F5B9-471AC478D10D}"/>
+                <a16:creationId xmlns:a16="http://schemas.microsoft.com/office/drawing/2014/main" id="{025E3224-F42B-E56D-67F5-21997BB8E02E}"/>
               </a:ext>
             </a:extLst>
           </p:cNvPr>
@@ -1656,7 +1752,7 @@
           <a:bodyPr/>
           <a:lstStyle/>
           <a:p>
-            <a:fld id="{54FF740A-2CFB-4C12-9B69-14E08326A350}" type="slidenum">
+            <a:fld id="{AB36B74C-88B0-43C8-957A-2BB332CCF888}" type="slidenum">
               <a:rPr lang="en-US" smtClean="0"/>
               <a:t>‹#›</a:t>
             </a:fld>
@@ -1667,7 +1763,7 @@
     </p:spTree>
     <p:extLst>
       <p:ext uri="{BB962C8B-B14F-4D97-AF65-F5344CB8AC3E}">
-        <p14:creationId xmlns:p14="http://schemas.microsoft.com/office/powerpoint/2010/main" val="1336037193"/>
+        <p14:creationId xmlns:p14="http://schemas.microsoft.com/office/powerpoint/2010/main" val="3161747405"/>
       </p:ext>
     </p:extLst>
   </p:cSld>
@@ -1699,7 +1795,7 @@
           <p:cNvPr id="2" name="Title 1">
             <a:extLst>
               <a:ext uri="{FF2B5EF4-FFF2-40B4-BE49-F238E27FC236}">
-                <a16:creationId xmlns:a16="http://schemas.microsoft.com/office/drawing/2014/main" id="{12EEF993-BFDD-9C2C-6E76-9B90F1843B0F}"/>
+                <a16:creationId xmlns:a16="http://schemas.microsoft.com/office/drawing/2014/main" id="{9B86A0C2-A78D-D77E-7EAA-14BF019BB1EE}"/>
               </a:ext>
             </a:extLst>
           </p:cNvPr>
@@ -1732,7 +1828,7 @@
           <p:cNvPr id="3" name="Text Placeholder 2">
             <a:extLst>
               <a:ext uri="{FF2B5EF4-FFF2-40B4-BE49-F238E27FC236}">
-                <a16:creationId xmlns:a16="http://schemas.microsoft.com/office/drawing/2014/main" id="{B36BCE18-E5AA-D107-96D3-1B512DBEDB3B}"/>
+                <a16:creationId xmlns:a16="http://schemas.microsoft.com/office/drawing/2014/main" id="{2DF8AEDE-494C-CE4B-A4C0-DBD9BF04DFB4}"/>
               </a:ext>
             </a:extLst>
           </p:cNvPr>
@@ -1803,7 +1899,7 @@
           <p:cNvPr id="4" name="Content Placeholder 3">
             <a:extLst>
               <a:ext uri="{FF2B5EF4-FFF2-40B4-BE49-F238E27FC236}">
-                <a16:creationId xmlns:a16="http://schemas.microsoft.com/office/drawing/2014/main" id="{76F61661-AD26-57A8-D506-18D9DFFEB5D4}"/>
+                <a16:creationId xmlns:a16="http://schemas.microsoft.com/office/drawing/2014/main" id="{1ACDC1F6-44BF-3CAB-7EE3-121D217A2B6E}"/>
               </a:ext>
             </a:extLst>
           </p:cNvPr>
@@ -1865,7 +1961,7 @@
           <p:cNvPr id="5" name="Text Placeholder 4">
             <a:extLst>
               <a:ext uri="{FF2B5EF4-FFF2-40B4-BE49-F238E27FC236}">
-                <a16:creationId xmlns:a16="http://schemas.microsoft.com/office/drawing/2014/main" id="{F736AD30-5D9C-F92D-D4AC-BBAE49D3D84F}"/>
+                <a16:creationId xmlns:a16="http://schemas.microsoft.com/office/drawing/2014/main" id="{E5285E3F-000C-D113-E500-BF92270F26EE}"/>
               </a:ext>
             </a:extLst>
           </p:cNvPr>
@@ -1936,7 +2032,7 @@
           <p:cNvPr id="6" name="Content Placeholder 5">
             <a:extLst>
               <a:ext uri="{FF2B5EF4-FFF2-40B4-BE49-F238E27FC236}">
-                <a16:creationId xmlns:a16="http://schemas.microsoft.com/office/drawing/2014/main" id="{3E33DDD0-E882-611C-F30D-50FE92893E59}"/>
+                <a16:creationId xmlns:a16="http://schemas.microsoft.com/office/drawing/2014/main" id="{0F5CDE75-D880-7459-043F-9CC301DB3888}"/>
               </a:ext>
             </a:extLst>
           </p:cNvPr>
@@ -1998,7 +2094,7 @@
           <p:cNvPr id="7" name="Date Placeholder 6">
             <a:extLst>
               <a:ext uri="{FF2B5EF4-FFF2-40B4-BE49-F238E27FC236}">
-                <a16:creationId xmlns:a16="http://schemas.microsoft.com/office/drawing/2014/main" id="{831B5EE9-E59E-4FBC-3B23-E7212316AB08}"/>
+                <a16:creationId xmlns:a16="http://schemas.microsoft.com/office/drawing/2014/main" id="{4458CDCA-C1A3-176C-ABFA-850298566AB7}"/>
               </a:ext>
             </a:extLst>
           </p:cNvPr>
@@ -2014,7 +2110,7 @@
           <a:bodyPr/>
           <a:lstStyle/>
           <a:p>
-            <a:fld id="{7C972402-98C4-49BE-9E44-3AE0CE18D547}" type="datetimeFigureOut">
+            <a:fld id="{3B04DCD2-51FF-4424-A8D0-554917C1B566}" type="datetimeFigureOut">
               <a:rPr lang="en-US" smtClean="0"/>
               <a:t>5/27/2026</a:t>
             </a:fld>
@@ -2027,7 +2123,7 @@
           <p:cNvPr id="8" name="Footer Placeholder 7">
             <a:extLst>
               <a:ext uri="{FF2B5EF4-FFF2-40B4-BE49-F238E27FC236}">
-                <a16:creationId xmlns:a16="http://schemas.microsoft.com/office/drawing/2014/main" id="{8DE57AB7-5CDB-7A92-9D7C-1367C4A89F48}"/>
+                <a16:creationId xmlns:a16="http://schemas.microsoft.com/office/drawing/2014/main" id="{9754042D-1C6B-D7B6-F45E-72A0020291F6}"/>
               </a:ext>
             </a:extLst>
           </p:cNvPr>
@@ -2052,7 +2148,7 @@
           <p:cNvPr id="9" name="Slide Number Placeholder 8">
             <a:extLst>
               <a:ext uri="{FF2B5EF4-FFF2-40B4-BE49-F238E27FC236}">
-                <a16:creationId xmlns:a16="http://schemas.microsoft.com/office/drawing/2014/main" id="{B6460BEC-653F-DE5E-E101-1878651B2ED2}"/>
+                <a16:creationId xmlns:a16="http://schemas.microsoft.com/office/drawing/2014/main" id="{D37A01D6-AAE5-1FA6-389A-B9F4B32E26E9}"/>
               </a:ext>
             </a:extLst>
           </p:cNvPr>
@@ -2068,7 +2164,7 @@
           <a:bodyPr/>
           <a:lstStyle/>
           <a:p>
-            <a:fld id="{54FF740A-2CFB-4C12-9B69-14E08326A350}" type="slidenum">
+            <a:fld id="{AB36B74C-88B0-43C8-957A-2BB332CCF888}" type="slidenum">
               <a:rPr lang="en-US" smtClean="0"/>
               <a:t>‹#›</a:t>
             </a:fld>
@@ -2079,7 +2175,7 @@
     </p:spTree>
     <p:extLst>
       <p:ext uri="{BB962C8B-B14F-4D97-AF65-F5344CB8AC3E}">
-        <p14:creationId xmlns:p14="http://schemas.microsoft.com/office/powerpoint/2010/main" val="1498329422"/>
+        <p14:creationId xmlns:p14="http://schemas.microsoft.com/office/powerpoint/2010/main" val="1636585996"/>
       </p:ext>
     </p:extLst>
   </p:cSld>
@@ -2111,7 +2207,7 @@
           <p:cNvPr id="2" name="Title 1">
             <a:extLst>
               <a:ext uri="{FF2B5EF4-FFF2-40B4-BE49-F238E27FC236}">
-                <a16:creationId xmlns:a16="http://schemas.microsoft.com/office/drawing/2014/main" id="{9C96E315-E9A3-97F9-7BD4-2EFBAB4B0C02}"/>
+                <a16:creationId xmlns:a16="http://schemas.microsoft.com/office/drawing/2014/main" id="{32B4A2D6-47D6-8AF9-EA4C-06442DD3375E}"/>
               </a:ext>
             </a:extLst>
           </p:cNvPr>
@@ -2139,7 +2235,7 @@
           <p:cNvPr id="3" name="Date Placeholder 2">
             <a:extLst>
               <a:ext uri="{FF2B5EF4-FFF2-40B4-BE49-F238E27FC236}">
-                <a16:creationId xmlns:a16="http://schemas.microsoft.com/office/drawing/2014/main" id="{DDF249B0-ECF1-CE2D-1841-8CAC77C7617D}"/>
+                <a16:creationId xmlns:a16="http://schemas.microsoft.com/office/drawing/2014/main" id="{8FCA8D79-E2A2-E931-2BE1-365EDEBBFF7C}"/>
               </a:ext>
             </a:extLst>
           </p:cNvPr>
@@ -2155,7 +2251,7 @@
           <a:bodyPr/>
           <a:lstStyle/>
           <a:p>
-            <a:fld id="{7C972402-98C4-49BE-9E44-3AE0CE18D547}" type="datetimeFigureOut">
+            <a:fld id="{3B04DCD2-51FF-4424-A8D0-554917C1B566}" type="datetimeFigureOut">
               <a:rPr lang="en-US" smtClean="0"/>
               <a:t>5/27/2026</a:t>
             </a:fld>
@@ -2168,7 +2264,7 @@
           <p:cNvPr id="4" name="Footer Placeholder 3">
             <a:extLst>
               <a:ext uri="{FF2B5EF4-FFF2-40B4-BE49-F238E27FC236}">
-                <a16:creationId xmlns:a16="http://schemas.microsoft.com/office/drawing/2014/main" id="{414A5919-3185-2A8A-171E-DF7111A65513}"/>
+                <a16:creationId xmlns:a16="http://schemas.microsoft.com/office/drawing/2014/main" id="{2B7A6946-72C1-323A-1BA6-945C94703178}"/>
               </a:ext>
             </a:extLst>
           </p:cNvPr>
@@ -2193,7 +2289,7 @@
           <p:cNvPr id="5" name="Slide Number Placeholder 4">
             <a:extLst>
               <a:ext uri="{FF2B5EF4-FFF2-40B4-BE49-F238E27FC236}">
-                <a16:creationId xmlns:a16="http://schemas.microsoft.com/office/drawing/2014/main" id="{ECBBC545-FEA3-9952-EFD0-978EDC6BD8B2}"/>
+                <a16:creationId xmlns:a16="http://schemas.microsoft.com/office/drawing/2014/main" id="{E28B7783-1403-04A9-33A0-C0132E45C314}"/>
               </a:ext>
             </a:extLst>
           </p:cNvPr>
@@ -2209,7 +2305,7 @@
           <a:bodyPr/>
           <a:lstStyle/>
           <a:p>
-            <a:fld id="{54FF740A-2CFB-4C12-9B69-14E08326A350}" type="slidenum">
+            <a:fld id="{AB36B74C-88B0-43C8-957A-2BB332CCF888}" type="slidenum">
               <a:rPr lang="en-US" smtClean="0"/>
               <a:t>‹#›</a:t>
             </a:fld>
@@ -2220,7 +2316,7 @@
     </p:spTree>
     <p:extLst>
       <p:ext uri="{BB962C8B-B14F-4D97-AF65-F5344CB8AC3E}">
-        <p14:creationId xmlns:p14="http://schemas.microsoft.com/office/powerpoint/2010/main" val="1047069098"/>
+        <p14:creationId xmlns:p14="http://schemas.microsoft.com/office/powerpoint/2010/main" val="3093300996"/>
       </p:ext>
     </p:extLst>
   </p:cSld>
@@ -2252,7 +2348,7 @@
           <p:cNvPr id="2" name="Date Placeholder 1">
             <a:extLst>
               <a:ext uri="{FF2B5EF4-FFF2-40B4-BE49-F238E27FC236}">
-                <a16:creationId xmlns:a16="http://schemas.microsoft.com/office/drawing/2014/main" id="{8F3B107F-8C6A-3075-A6C7-69D8FDAB8CAE}"/>
+                <a16:creationId xmlns:a16="http://schemas.microsoft.com/office/drawing/2014/main" id="{8AD93316-7C2D-4136-8196-70541135E704}"/>
               </a:ext>
             </a:extLst>
           </p:cNvPr>
@@ -2268,7 +2364,7 @@
           <a:bodyPr/>
           <a:lstStyle/>
           <a:p>
-            <a:fld id="{7C972402-98C4-49BE-9E44-3AE0CE18D547}" type="datetimeFigureOut">
+            <a:fld id="{3B04DCD2-51FF-4424-A8D0-554917C1B566}" type="datetimeFigureOut">
               <a:rPr lang="en-US" smtClean="0"/>
               <a:t>5/27/2026</a:t>
             </a:fld>
@@ -2281,7 +2377,7 @@
           <p:cNvPr id="3" name="Footer Placeholder 2">
             <a:extLst>
               <a:ext uri="{FF2B5EF4-FFF2-40B4-BE49-F238E27FC236}">
-                <a16:creationId xmlns:a16="http://schemas.microsoft.com/office/drawing/2014/main" id="{30B85476-202C-FACE-9117-D894871A5D12}"/>
+                <a16:creationId xmlns:a16="http://schemas.microsoft.com/office/drawing/2014/main" id="{982ECF52-2C88-2E3F-BEBC-D38B42ECE646}"/>
               </a:ext>
             </a:extLst>
           </p:cNvPr>
@@ -2306,7 +2402,7 @@
           <p:cNvPr id="4" name="Slide Number Placeholder 3">
             <a:extLst>
               <a:ext uri="{FF2B5EF4-FFF2-40B4-BE49-F238E27FC236}">
-                <a16:creationId xmlns:a16="http://schemas.microsoft.com/office/drawing/2014/main" id="{CFC112B5-EDE5-F0EC-47EB-7B2E3C570F45}"/>
+                <a16:creationId xmlns:a16="http://schemas.microsoft.com/office/drawing/2014/main" id="{C1D7C7CC-AABF-48FE-69AC-39EEA7260F9F}"/>
               </a:ext>
             </a:extLst>
           </p:cNvPr>
@@ -2322,7 +2418,7 @@
           <a:bodyPr/>
           <a:lstStyle/>
           <a:p>
-            <a:fld id="{54FF740A-2CFB-4C12-9B69-14E08326A350}" type="slidenum">
+            <a:fld id="{AB36B74C-88B0-43C8-957A-2BB332CCF888}" type="slidenum">
               <a:rPr lang="en-US" smtClean="0"/>
               <a:t>‹#›</a:t>
             </a:fld>
@@ -2333,7 +2429,7 @@
     </p:spTree>
     <p:extLst>
       <p:ext uri="{BB962C8B-B14F-4D97-AF65-F5344CB8AC3E}">
-        <p14:creationId xmlns:p14="http://schemas.microsoft.com/office/powerpoint/2010/main" val="3766079815"/>
+        <p14:creationId xmlns:p14="http://schemas.microsoft.com/office/powerpoint/2010/main" val="1716825024"/>
       </p:ext>
     </p:extLst>
   </p:cSld>
@@ -2365,7 +2461,7 @@
           <p:cNvPr id="2" name="Title 1">
             <a:extLst>
               <a:ext uri="{FF2B5EF4-FFF2-40B4-BE49-F238E27FC236}">
-                <a16:creationId xmlns:a16="http://schemas.microsoft.com/office/drawing/2014/main" id="{1768E8DC-BC5F-FBBE-2049-1EA7F57C3442}"/>
+                <a16:creationId xmlns:a16="http://schemas.microsoft.com/office/drawing/2014/main" id="{BF948953-A100-8F69-4F77-E360A32630AE}"/>
               </a:ext>
             </a:extLst>
           </p:cNvPr>
@@ -2402,7 +2498,7 @@
           <p:cNvPr id="3" name="Content Placeholder 2">
             <a:extLst>
               <a:ext uri="{FF2B5EF4-FFF2-40B4-BE49-F238E27FC236}">
-                <a16:creationId xmlns:a16="http://schemas.microsoft.com/office/drawing/2014/main" id="{624018D9-7410-944D-B6A3-D4680C74A308}"/>
+                <a16:creationId xmlns:a16="http://schemas.microsoft.com/office/drawing/2014/main" id="{B6311BBF-DC1B-07AD-DF4F-FF125C81CCC3}"/>
               </a:ext>
             </a:extLst>
           </p:cNvPr>
@@ -2492,7 +2588,7 @@
           <p:cNvPr id="4" name="Text Placeholder 3">
             <a:extLst>
               <a:ext uri="{FF2B5EF4-FFF2-40B4-BE49-F238E27FC236}">
-                <a16:creationId xmlns:a16="http://schemas.microsoft.com/office/drawing/2014/main" id="{5913141B-AF12-636A-A955-9B311880D4C8}"/>
+                <a16:creationId xmlns:a16="http://schemas.microsoft.com/office/drawing/2014/main" id="{60B70BC2-6166-8C4C-9080-AAF595295209}"/>
               </a:ext>
             </a:extLst>
           </p:cNvPr>
@@ -2563,7 +2659,7 @@
           <p:cNvPr id="5" name="Date Placeholder 4">
             <a:extLst>
               <a:ext uri="{FF2B5EF4-FFF2-40B4-BE49-F238E27FC236}">
-                <a16:creationId xmlns:a16="http://schemas.microsoft.com/office/drawing/2014/main" id="{73007996-BE8D-1580-E501-D2322535B521}"/>
+                <a16:creationId xmlns:a16="http://schemas.microsoft.com/office/drawing/2014/main" id="{6AEB6D0D-AA68-D8D2-31AC-4C1BDFB00F24}"/>
               </a:ext>
             </a:extLst>
           </p:cNvPr>
@@ -2579,7 +2675,7 @@
           <a:bodyPr/>
           <a:lstStyle/>
           <a:p>
-            <a:fld id="{7C972402-98C4-49BE-9E44-3AE0CE18D547}" type="datetimeFigureOut">
+            <a:fld id="{3B04DCD2-51FF-4424-A8D0-554917C1B566}" type="datetimeFigureOut">
               <a:rPr lang="en-US" smtClean="0"/>
               <a:t>5/27/2026</a:t>
             </a:fld>
@@ -2592,7 +2688,7 @@
           <p:cNvPr id="6" name="Footer Placeholder 5">
             <a:extLst>
               <a:ext uri="{FF2B5EF4-FFF2-40B4-BE49-F238E27FC236}">
-                <a16:creationId xmlns:a16="http://schemas.microsoft.com/office/drawing/2014/main" id="{193BF727-CBB8-1DDE-D54D-6CFEB89E352F}"/>
+                <a16:creationId xmlns:a16="http://schemas.microsoft.com/office/drawing/2014/main" id="{D31D8D37-423D-4061-2A0F-1783A2C11963}"/>
               </a:ext>
             </a:extLst>
           </p:cNvPr>
@@ -2617,7 +2713,7 @@
           <p:cNvPr id="7" name="Slide Number Placeholder 6">
             <a:extLst>
               <a:ext uri="{FF2B5EF4-FFF2-40B4-BE49-F238E27FC236}">
-                <a16:creationId xmlns:a16="http://schemas.microsoft.com/office/drawing/2014/main" id="{264B144E-B4FC-F34C-4792-EC01CBAB8468}"/>
+                <a16:creationId xmlns:a16="http://schemas.microsoft.com/office/drawing/2014/main" id="{AF94B4E3-4981-F7CC-5443-66C7BC9B260E}"/>
               </a:ext>
             </a:extLst>
           </p:cNvPr>
@@ -2633,7 +2729,7 @@
           <a:bodyPr/>
           <a:lstStyle/>
           <a:p>
-            <a:fld id="{54FF740A-2CFB-4C12-9B69-14E08326A350}" type="slidenum">
+            <a:fld id="{AB36B74C-88B0-43C8-957A-2BB332CCF888}" type="slidenum">
               <a:rPr lang="en-US" smtClean="0"/>
               <a:t>‹#›</a:t>
             </a:fld>
@@ -2644,7 +2740,7 @@
     </p:spTree>
     <p:extLst>
       <p:ext uri="{BB962C8B-B14F-4D97-AF65-F5344CB8AC3E}">
-        <p14:creationId xmlns:p14="http://schemas.microsoft.com/office/powerpoint/2010/main" val="2443564860"/>
+        <p14:creationId xmlns:p14="http://schemas.microsoft.com/office/powerpoint/2010/main" val="658799276"/>
       </p:ext>
     </p:extLst>
   </p:cSld>
@@ -2676,7 +2772,7 @@
           <p:cNvPr id="2" name="Title 1">
             <a:extLst>
               <a:ext uri="{FF2B5EF4-FFF2-40B4-BE49-F238E27FC236}">
-                <a16:creationId xmlns:a16="http://schemas.microsoft.com/office/drawing/2014/main" id="{BA149347-2203-C04C-5A74-6A026F3F81B2}"/>
+                <a16:creationId xmlns:a16="http://schemas.microsoft.com/office/drawing/2014/main" id="{FE9F0C86-601D-C760-F64C-7CC8EFB3DED7}"/>
               </a:ext>
             </a:extLst>
           </p:cNvPr>
@@ -2713,7 +2809,7 @@
           <p:cNvPr id="3" name="Picture Placeholder 2">
             <a:extLst>
               <a:ext uri="{FF2B5EF4-FFF2-40B4-BE49-F238E27FC236}">
-                <a16:creationId xmlns:a16="http://schemas.microsoft.com/office/drawing/2014/main" id="{5B58F711-AC24-30A6-863A-686B760C9A22}"/>
+                <a16:creationId xmlns:a16="http://schemas.microsoft.com/office/drawing/2014/main" id="{17716703-DCAD-C3FD-5682-E6228FBA907B}"/>
               </a:ext>
             </a:extLst>
           </p:cNvPr>
@@ -2780,7 +2876,7 @@
           <p:cNvPr id="4" name="Text Placeholder 3">
             <a:extLst>
               <a:ext uri="{FF2B5EF4-FFF2-40B4-BE49-F238E27FC236}">
-                <a16:creationId xmlns:a16="http://schemas.microsoft.com/office/drawing/2014/main" id="{E1CA3DB5-560F-08D5-B34E-D2BD549AD361}"/>
+                <a16:creationId xmlns:a16="http://schemas.microsoft.com/office/drawing/2014/main" id="{CB7CA4F8-8DEA-881D-1E86-6DC191CEB3C8}"/>
               </a:ext>
             </a:extLst>
           </p:cNvPr>
@@ -2851,7 +2947,7 @@
           <p:cNvPr id="5" name="Date Placeholder 4">
             <a:extLst>
               <a:ext uri="{FF2B5EF4-FFF2-40B4-BE49-F238E27FC236}">
-                <a16:creationId xmlns:a16="http://schemas.microsoft.com/office/drawing/2014/main" id="{C905F0CC-1206-1896-E26B-1B23329B64E3}"/>
+                <a16:creationId xmlns:a16="http://schemas.microsoft.com/office/drawing/2014/main" id="{E220FF17-8DB3-F8E3-B440-8060122D3010}"/>
               </a:ext>
             </a:extLst>
           </p:cNvPr>
@@ -2867,7 +2963,7 @@
           <a:bodyPr/>
           <a:lstStyle/>
           <a:p>
-            <a:fld id="{7C972402-98C4-49BE-9E44-3AE0CE18D547}" type="datetimeFigureOut">
+            <a:fld id="{3B04DCD2-51FF-4424-A8D0-554917C1B566}" type="datetimeFigureOut">
               <a:rPr lang="en-US" smtClean="0"/>
               <a:t>5/27/2026</a:t>
             </a:fld>
@@ -2880,7 +2976,7 @@
           <p:cNvPr id="6" name="Footer Placeholder 5">
             <a:extLst>
               <a:ext uri="{FF2B5EF4-FFF2-40B4-BE49-F238E27FC236}">
-                <a16:creationId xmlns:a16="http://schemas.microsoft.com/office/drawing/2014/main" id="{8C684AB1-A3C0-B366-9DDA-6EF33FE67585}"/>
+                <a16:creationId xmlns:a16="http://schemas.microsoft.com/office/drawing/2014/main" id="{61234EE8-1CD1-4D65-5B48-51952BAB472A}"/>
               </a:ext>
             </a:extLst>
           </p:cNvPr>
@@ -2905,7 +3001,7 @@
           <p:cNvPr id="7" name="Slide Number Placeholder 6">
             <a:extLst>
               <a:ext uri="{FF2B5EF4-FFF2-40B4-BE49-F238E27FC236}">
-                <a16:creationId xmlns:a16="http://schemas.microsoft.com/office/drawing/2014/main" id="{9F49737C-7285-1E5A-22C6-7D271CFC5F16}"/>
+                <a16:creationId xmlns:a16="http://schemas.microsoft.com/office/drawing/2014/main" id="{62FDF4B3-EBAF-2C2B-8812-69BBF47418CE}"/>
               </a:ext>
             </a:extLst>
           </p:cNvPr>
@@ -2921,7 +3017,7 @@
           <a:bodyPr/>
           <a:lstStyle/>
           <a:p>
-            <a:fld id="{54FF740A-2CFB-4C12-9B69-14E08326A350}" type="slidenum">
+            <a:fld id="{AB36B74C-88B0-43C8-957A-2BB332CCF888}" type="slidenum">
               <a:rPr lang="en-US" smtClean="0"/>
               <a:t>‹#›</a:t>
             </a:fld>
@@ -2932,7 +3028,7 @@
     </p:spTree>
     <p:extLst>
       <p:ext uri="{BB962C8B-B14F-4D97-AF65-F5344CB8AC3E}">
-        <p14:creationId xmlns:p14="http://schemas.microsoft.com/office/powerpoint/2010/main" val="593108219"/>
+        <p14:creationId xmlns:p14="http://schemas.microsoft.com/office/powerpoint/2010/main" val="443600406"/>
       </p:ext>
     </p:extLst>
   </p:cSld>
@@ -2969,7 +3065,7 @@
           <p:cNvPr id="2" name="Title Placeholder 1">
             <a:extLst>
               <a:ext uri="{FF2B5EF4-FFF2-40B4-BE49-F238E27FC236}">
-                <a16:creationId xmlns:a16="http://schemas.microsoft.com/office/drawing/2014/main" id="{9E10BE4F-4D1E-7598-1C65-024200BE75DB}"/>
+                <a16:creationId xmlns:a16="http://schemas.microsoft.com/office/drawing/2014/main" id="{A6678519-1D24-DE8E-1C0C-E7B71F0CEA6F}"/>
               </a:ext>
             </a:extLst>
           </p:cNvPr>
@@ -3007,7 +3103,7 @@
           <p:cNvPr id="3" name="Text Placeholder 2">
             <a:extLst>
               <a:ext uri="{FF2B5EF4-FFF2-40B4-BE49-F238E27FC236}">
-                <a16:creationId xmlns:a16="http://schemas.microsoft.com/office/drawing/2014/main" id="{8A650AF3-89CB-01BD-5BDF-0212CA0B917B}"/>
+                <a16:creationId xmlns:a16="http://schemas.microsoft.com/office/drawing/2014/main" id="{F21B958B-6C88-54F5-9A3B-7AD2986D288C}"/>
               </a:ext>
             </a:extLst>
           </p:cNvPr>
@@ -3074,7 +3170,7 @@
           <p:cNvPr id="4" name="Date Placeholder 3">
             <a:extLst>
               <a:ext uri="{FF2B5EF4-FFF2-40B4-BE49-F238E27FC236}">
-                <a16:creationId xmlns:a16="http://schemas.microsoft.com/office/drawing/2014/main" id="{24D61DEC-5D11-3A30-9980-E31EE831518A}"/>
+                <a16:creationId xmlns:a16="http://schemas.microsoft.com/office/drawing/2014/main" id="{B9280330-2808-9D6F-10A3-64134EE32191}"/>
               </a:ext>
             </a:extLst>
           </p:cNvPr>
@@ -3108,7 +3204,7 @@
             </a:lvl1pPr>
           </a:lstStyle>
           <a:p>
-            <a:fld id="{7C972402-98C4-49BE-9E44-3AE0CE18D547}" type="datetimeFigureOut">
+            <a:fld id="{3B04DCD2-51FF-4424-A8D0-554917C1B566}" type="datetimeFigureOut">
               <a:rPr lang="en-US" smtClean="0"/>
               <a:t>5/27/2026</a:t>
             </a:fld>
@@ -3121,7 +3217,7 @@
           <p:cNvPr id="5" name="Footer Placeholder 4">
             <a:extLst>
               <a:ext uri="{FF2B5EF4-FFF2-40B4-BE49-F238E27FC236}">
-                <a16:creationId xmlns:a16="http://schemas.microsoft.com/office/drawing/2014/main" id="{E9FF9F5A-CDEC-1CE9-8155-FC0A0446AF2B}"/>
+                <a16:creationId xmlns:a16="http://schemas.microsoft.com/office/drawing/2014/main" id="{AE765D20-3810-275A-3155-C45B0F37ED10}"/>
               </a:ext>
             </a:extLst>
           </p:cNvPr>
@@ -3164,7 +3260,7 @@
           <p:cNvPr id="6" name="Slide Number Placeholder 5">
             <a:extLst>
               <a:ext uri="{FF2B5EF4-FFF2-40B4-BE49-F238E27FC236}">
-                <a16:creationId xmlns:a16="http://schemas.microsoft.com/office/drawing/2014/main" id="{AA33DA84-582C-BCF8-380B-C55357EA102E}"/>
+                <a16:creationId xmlns:a16="http://schemas.microsoft.com/office/drawing/2014/main" id="{A1663C36-0A70-68E0-947E-A23CFBEB1E65}"/>
               </a:ext>
             </a:extLst>
           </p:cNvPr>
@@ -3198,7 +3294,7 @@
             </a:lvl1pPr>
           </a:lstStyle>
           <a:p>
-            <a:fld id="{54FF740A-2CFB-4C12-9B69-14E08326A350}" type="slidenum">
+            <a:fld id="{AB36B74C-88B0-43C8-957A-2BB332CCF888}" type="slidenum">
               <a:rPr lang="en-US" smtClean="0"/>
               <a:t>‹#›</a:t>
             </a:fld>
@@ -3209,7 +3305,7 @@
     </p:spTree>
     <p:extLst>
       <p:ext uri="{BB962C8B-B14F-4D97-AF65-F5344CB8AC3E}">
-        <p14:creationId xmlns:p14="http://schemas.microsoft.com/office/powerpoint/2010/main" val="61216562"/>
+        <p14:creationId xmlns:p14="http://schemas.microsoft.com/office/powerpoint/2010/main" val="1532393703"/>
       </p:ext>
     </p:extLst>
   </p:cSld>
@@ -3532,7 +3628,7 @@
           <p:cNvPr id="2" name="Chart 1">
             <a:extLst>
               <a:ext uri="{FF2B5EF4-FFF2-40B4-BE49-F238E27FC236}">
-                <a16:creationId xmlns:a16="http://schemas.microsoft.com/office/drawing/2014/main" id="{09FD498D-BF1A-623C-775A-AACDDDEA5BB9}"/>
+                <a16:creationId xmlns:a16="http://schemas.microsoft.com/office/drawing/2014/main" id="{786DCFC8-C050-6522-DF11-71479FC3AEE8}"/>
               </a:ext>
             </a:extLst>
           </p:cNvPr>
@@ -3540,7 +3636,7 @@
           <p:nvPr>
             <p:extLst>
               <p:ext uri="{D42A27DB-BD31-4B8C-83A1-F6EECF244321}">
-                <p14:modId xmlns:p14="http://schemas.microsoft.com/office/powerpoint/2010/main" val="1282402310"/>
+                <p14:modId xmlns:p14="http://schemas.microsoft.com/office/powerpoint/2010/main" val="2795304778"/>
               </p:ext>
             </p:extLst>
           </p:nvPr>
@@ -3558,7 +3654,7 @@
     </p:spTree>
     <p:extLst>
       <p:ext uri="{BB962C8B-B14F-4D97-AF65-F5344CB8AC3E}">
-        <p14:creationId xmlns:p14="http://schemas.microsoft.com/office/powerpoint/2010/main" val="2806293202"/>
+        <p14:creationId xmlns:p14="http://schemas.microsoft.com/office/powerpoint/2010/main" val="1790419625"/>
       </p:ext>
     </p:extLst>
   </p:cSld>

</xml_diff>

<commit_message>
Expose chart leader line probe
</commit_message>
<xml_diff>
--- a/tests/Lokad.OoxPdf.Tests/Cases/pptx-ladder-11-chart-pie-data-label-leader-lines-probe.pptx
+++ b/tests/Lokad.OoxPdf.Tests/Cases/pptx-ladder-11-chart-pie-data-label-leader-lines-probe.pptx
@@ -150,7 +150,7 @@
             </c:spPr>
             <c:extLst>
               <c:ext xmlns:c16="http://schemas.microsoft.com/office/drawing/2014/chart" uri="{C3380CC4-5D6E-409C-BE32-E72D297353CC}">
-                <c16:uniqueId val="{00000001-595E-40CF-AEDC-215BCE2ACEE7}"/>
+                <c16:uniqueId val="{00000001-20AE-46CB-AEA5-2824D0ECAF50}"/>
               </c:ext>
             </c:extLst>
           </c:dPt>
@@ -164,7 +164,7 @@
             </c:spPr>
             <c:extLst>
               <c:ext xmlns:c16="http://schemas.microsoft.com/office/drawing/2014/chart" uri="{C3380CC4-5D6E-409C-BE32-E72D297353CC}">
-                <c16:uniqueId val="{00000002-595E-40CF-AEDC-215BCE2ACEE7}"/>
+                <c16:uniqueId val="{00000002-20AE-46CB-AEA5-2824D0ECAF50}"/>
               </c:ext>
             </c:extLst>
           </c:dPt>
@@ -178,7 +178,7 @@
             </c:spPr>
             <c:extLst>
               <c:ext xmlns:c16="http://schemas.microsoft.com/office/drawing/2014/chart" uri="{C3380CC4-5D6E-409C-BE32-E72D297353CC}">
-                <c16:uniqueId val="{00000003-595E-40CF-AEDC-215BCE2ACEE7}"/>
+                <c16:uniqueId val="{00000003-20AE-46CB-AEA5-2824D0ECAF50}"/>
               </c:ext>
             </c:extLst>
           </c:dPt>
@@ -192,7 +192,7 @@
             </c:spPr>
             <c:extLst>
               <c:ext xmlns:c16="http://schemas.microsoft.com/office/drawing/2014/chart" uri="{C3380CC4-5D6E-409C-BE32-E72D297353CC}">
-                <c16:uniqueId val="{00000004-595E-40CF-AEDC-215BCE2ACEE7}"/>
+                <c16:uniqueId val="{00000004-20AE-46CB-AEA5-2824D0ECAF50}"/>
               </c:ext>
             </c:extLst>
           </c:dPt>
@@ -201,23 +201,22 @@
               <c:idx val="0"/>
               <c:layout>
                 <c:manualLayout>
-                  <c:x val="-0.67258721566054247"/>
-                  <c:y val="-0.32275371828521437"/>
+                  <c:x val="-0.77024076317383405"/>
+                  <c:y val="-0.36989654418197726"/>
                 </c:manualLayout>
               </c:layout>
               <c:dLblPos val="bestFit"/>
-              <c:showLegendKey val="1"/>
+              <c:showLegendKey val="0"/>
               <c:showVal val="0"/>
               <c:showCatName val="1"/>
               <c:showSerName val="0"/>
               <c:showPercent val="1"/>
               <c:showBubbleSize val="0"/>
-              <c:separator>
-</c:separator>
+              <c:separator> </c:separator>
               <c:extLst>
                 <c:ext xmlns:c15="http://schemas.microsoft.com/office/drawing/2012/chart" uri="{CE6537A1-D6FC-4f65-9D91-7224C49458BB}"/>
                 <c:ext xmlns:c16="http://schemas.microsoft.com/office/drawing/2014/chart" uri="{C3380CC4-5D6E-409C-BE32-E72D297353CC}">
-                  <c16:uniqueId val="{00000001-595E-40CF-AEDC-215BCE2ACEE7}"/>
+                  <c16:uniqueId val="{00000001-20AE-46CB-AEA5-2824D0ECAF50}"/>
                 </c:ext>
               </c:extLst>
             </c:dLbl>
@@ -225,23 +224,22 @@
               <c:idx val="1"/>
               <c:layout>
                 <c:manualLayout>
-                  <c:x val="0.59602321194225727"/>
-                  <c:y val="-0.43125437445319337"/>
+                  <c:x val="0.66015430042398549"/>
+                  <c:y val="-0.73511592300962381"/>
                 </c:manualLayout>
               </c:layout>
               <c:dLblPos val="bestFit"/>
-              <c:showLegendKey val="1"/>
+              <c:showLegendKey val="0"/>
               <c:showVal val="0"/>
               <c:showCatName val="1"/>
               <c:showSerName val="0"/>
               <c:showPercent val="1"/>
               <c:showBubbleSize val="0"/>
-              <c:separator>
-</c:separator>
+              <c:separator> </c:separator>
               <c:extLst>
                 <c:ext xmlns:c15="http://schemas.microsoft.com/office/drawing/2012/chart" uri="{CE6537A1-D6FC-4f65-9D91-7224C49458BB}"/>
                 <c:ext xmlns:c16="http://schemas.microsoft.com/office/drawing/2014/chart" uri="{C3380CC4-5D6E-409C-BE32-E72D297353CC}">
-                  <c16:uniqueId val="{00000002-595E-40CF-AEDC-215BCE2ACEE7}"/>
+                  <c16:uniqueId val="{00000002-20AE-46CB-AEA5-2824D0ECAF50}"/>
                 </c:ext>
               </c:extLst>
             </c:dLbl>
@@ -249,23 +247,22 @@
               <c:idx val="2"/>
               <c:layout>
                 <c:manualLayout>
-                  <c:x val="7.7810996281714784E-2"/>
-                  <c:y val="0.2432843030037912"/>
+                  <c:x val="-7.016278013325257E-2"/>
+                  <c:y val="0.54170122484689409"/>
                 </c:manualLayout>
               </c:layout>
               <c:dLblPos val="bestFit"/>
-              <c:showLegendKey val="1"/>
+              <c:showLegendKey val="0"/>
               <c:showVal val="0"/>
               <c:showCatName val="1"/>
               <c:showSerName val="0"/>
               <c:showPercent val="1"/>
               <c:showBubbleSize val="0"/>
-              <c:separator>
-</c:separator>
+              <c:separator> </c:separator>
               <c:extLst>
                 <c:ext xmlns:c15="http://schemas.microsoft.com/office/drawing/2012/chart" uri="{CE6537A1-D6FC-4f65-9D91-7224C49458BB}"/>
                 <c:ext xmlns:c16="http://schemas.microsoft.com/office/drawing/2014/chart" uri="{C3380CC4-5D6E-409C-BE32-E72D297353CC}">
-                  <c16:uniqueId val="{00000003-595E-40CF-AEDC-215BCE2ACEE7}"/>
+                  <c16:uniqueId val="{00000003-20AE-46CB-AEA5-2824D0ECAF50}"/>
                 </c:ext>
               </c:extLst>
             </c:dLbl>
@@ -273,23 +270,22 @@
               <c:idx val="3"/>
               <c:layout>
                 <c:manualLayout>
-                  <c:x val="3.0550634295713038E-2"/>
-                  <c:y val="0.87037037037037035"/>
+                  <c:x val="0.61921804966686855"/>
+                  <c:y val="0.88841426071741036"/>
                 </c:manualLayout>
               </c:layout>
               <c:dLblPos val="bestFit"/>
-              <c:showLegendKey val="1"/>
+              <c:showLegendKey val="0"/>
               <c:showVal val="0"/>
               <c:showCatName val="1"/>
               <c:showSerName val="0"/>
               <c:showPercent val="1"/>
               <c:showBubbleSize val="0"/>
-              <c:separator>
-</c:separator>
+              <c:separator> </c:separator>
               <c:extLst>
                 <c:ext xmlns:c15="http://schemas.microsoft.com/office/drawing/2012/chart" uri="{CE6537A1-D6FC-4f65-9D91-7224C49458BB}"/>
                 <c:ext xmlns:c16="http://schemas.microsoft.com/office/drawing/2014/chart" uri="{C3380CC4-5D6E-409C-BE32-E72D297353CC}">
-                  <c16:uniqueId val="{00000004-595E-40CF-AEDC-215BCE2ACEE7}"/>
+                  <c16:uniqueId val="{00000004-20AE-46CB-AEA5-2824D0ECAF50}"/>
                 </c:ext>
               </c:extLst>
             </c:dLbl>
@@ -301,20 +297,19 @@
               <a:effectLst/>
             </c:spPr>
             <c:dLblPos val="outEnd"/>
-            <c:showLegendKey val="1"/>
+            <c:showLegendKey val="0"/>
             <c:showVal val="0"/>
             <c:showCatName val="1"/>
             <c:showSerName val="0"/>
             <c:showPercent val="1"/>
             <c:showBubbleSize val="0"/>
-            <c:separator>
-</c:separator>
+            <c:separator> </c:separator>
             <c:showLeaderLines val="1"/>
             <c:leaderLines>
               <c:spPr>
-                <a:ln w="9525">
+                <a:ln w="28575">
                   <a:solidFill>
-                    <a:srgbClr val="595959"/>
+                    <a:srgbClr val="FF0000"/>
                   </a:solidFill>
                 </a:ln>
               </c:spPr>
@@ -366,7 +361,7 @@
           </c:val>
           <c:extLst>
             <c:ext xmlns:c16="http://schemas.microsoft.com/office/drawing/2014/chart" uri="{C3380CC4-5D6E-409C-BE32-E72D297353CC}">
-              <c16:uniqueId val="{00000000-595E-40CF-AEDC-215BCE2ACEE7}"/>
+              <c16:uniqueId val="{00000000-20AE-46CB-AEA5-2824D0ECAF50}"/>
             </c:ext>
           </c:extLst>
         </c:ser>
@@ -431,7 +426,7 @@
           <p:cNvPr id="2" name="Title 1">
             <a:extLst>
               <a:ext uri="{FF2B5EF4-FFF2-40B4-BE49-F238E27FC236}">
-                <a16:creationId xmlns:a16="http://schemas.microsoft.com/office/drawing/2014/main" id="{162AE65C-061F-1EC8-FE04-589A3F32DADD}"/>
+                <a16:creationId xmlns:a16="http://schemas.microsoft.com/office/drawing/2014/main" id="{FB0164D3-0E8F-BC87-EB7B-A784A923B177}"/>
               </a:ext>
             </a:extLst>
           </p:cNvPr>
@@ -468,7 +463,7 @@
           <p:cNvPr id="3" name="Subtitle 2">
             <a:extLst>
               <a:ext uri="{FF2B5EF4-FFF2-40B4-BE49-F238E27FC236}">
-                <a16:creationId xmlns:a16="http://schemas.microsoft.com/office/drawing/2014/main" id="{A981B51A-EEB0-0631-11AE-D189C91B7BE0}"/>
+                <a16:creationId xmlns:a16="http://schemas.microsoft.com/office/drawing/2014/main" id="{FD16DDCF-A64E-A1F5-062D-B32FB74C268D}"/>
               </a:ext>
             </a:extLst>
           </p:cNvPr>
@@ -538,7 +533,7 @@
           <p:cNvPr id="4" name="Date Placeholder 3">
             <a:extLst>
               <a:ext uri="{FF2B5EF4-FFF2-40B4-BE49-F238E27FC236}">
-                <a16:creationId xmlns:a16="http://schemas.microsoft.com/office/drawing/2014/main" id="{6905DAE0-DDB2-9CD8-2EFB-3DE67FFB1D1C}"/>
+                <a16:creationId xmlns:a16="http://schemas.microsoft.com/office/drawing/2014/main" id="{A498D98D-2EC1-0ED8-5274-AA6B24F5DFC0}"/>
               </a:ext>
             </a:extLst>
           </p:cNvPr>
@@ -554,7 +549,7 @@
           <a:bodyPr/>
           <a:lstStyle/>
           <a:p>
-            <a:fld id="{3B04DCD2-51FF-4424-A8D0-554917C1B566}" type="datetimeFigureOut">
+            <a:fld id="{248CC083-DEBD-4D69-8B9A-5124E7F9EAC4}" type="datetimeFigureOut">
               <a:rPr lang="en-US" smtClean="0"/>
               <a:t>5/27/2026</a:t>
             </a:fld>
@@ -567,7 +562,7 @@
           <p:cNvPr id="5" name="Footer Placeholder 4">
             <a:extLst>
               <a:ext uri="{FF2B5EF4-FFF2-40B4-BE49-F238E27FC236}">
-                <a16:creationId xmlns:a16="http://schemas.microsoft.com/office/drawing/2014/main" id="{1E852E90-7800-C5B0-A50E-DD16FDEF2369}"/>
+                <a16:creationId xmlns:a16="http://schemas.microsoft.com/office/drawing/2014/main" id="{85BD6FB5-E159-35BE-55ED-EED72D0ADB54}"/>
               </a:ext>
             </a:extLst>
           </p:cNvPr>
@@ -592,7 +587,7 @@
           <p:cNvPr id="6" name="Slide Number Placeholder 5">
             <a:extLst>
               <a:ext uri="{FF2B5EF4-FFF2-40B4-BE49-F238E27FC236}">
-                <a16:creationId xmlns:a16="http://schemas.microsoft.com/office/drawing/2014/main" id="{4B623324-B93A-9661-0F09-1923CC1F6DD7}"/>
+                <a16:creationId xmlns:a16="http://schemas.microsoft.com/office/drawing/2014/main" id="{49373500-596D-EAC1-13C2-0898EE042630}"/>
               </a:ext>
             </a:extLst>
           </p:cNvPr>
@@ -608,7 +603,7 @@
           <a:bodyPr/>
           <a:lstStyle/>
           <a:p>
-            <a:fld id="{AB36B74C-88B0-43C8-957A-2BB332CCF888}" type="slidenum">
+            <a:fld id="{E9775BDE-1FD4-4F3F-94CA-6D2F775373B6}" type="slidenum">
               <a:rPr lang="en-US" smtClean="0"/>
               <a:t>‹#›</a:t>
             </a:fld>
@@ -619,7 +614,7 @@
     </p:spTree>
     <p:extLst>
       <p:ext uri="{BB962C8B-B14F-4D97-AF65-F5344CB8AC3E}">
-        <p14:creationId xmlns:p14="http://schemas.microsoft.com/office/powerpoint/2010/main" val="2606980311"/>
+        <p14:creationId xmlns:p14="http://schemas.microsoft.com/office/powerpoint/2010/main" val="3706882587"/>
       </p:ext>
     </p:extLst>
   </p:cSld>
@@ -651,7 +646,7 @@
           <p:cNvPr id="2" name="Title 1">
             <a:extLst>
               <a:ext uri="{FF2B5EF4-FFF2-40B4-BE49-F238E27FC236}">
-                <a16:creationId xmlns:a16="http://schemas.microsoft.com/office/drawing/2014/main" id="{0A313C5C-DAFC-AFDB-660E-ABF2FF666221}"/>
+                <a16:creationId xmlns:a16="http://schemas.microsoft.com/office/drawing/2014/main" id="{209C448A-7C19-6B5E-B3D1-73A27880CA90}"/>
               </a:ext>
             </a:extLst>
           </p:cNvPr>
@@ -679,7 +674,7 @@
           <p:cNvPr id="3" name="Vertical Text Placeholder 2">
             <a:extLst>
               <a:ext uri="{FF2B5EF4-FFF2-40B4-BE49-F238E27FC236}">
-                <a16:creationId xmlns:a16="http://schemas.microsoft.com/office/drawing/2014/main" id="{A3BFDB55-799D-0516-A2CE-CFEB682B3406}"/>
+                <a16:creationId xmlns:a16="http://schemas.microsoft.com/office/drawing/2014/main" id="{F16D19B4-F298-6025-501B-17D79F247AA9}"/>
               </a:ext>
             </a:extLst>
           </p:cNvPr>
@@ -736,7 +731,7 @@
           <p:cNvPr id="4" name="Date Placeholder 3">
             <a:extLst>
               <a:ext uri="{FF2B5EF4-FFF2-40B4-BE49-F238E27FC236}">
-                <a16:creationId xmlns:a16="http://schemas.microsoft.com/office/drawing/2014/main" id="{012FF424-C4EB-B3EE-5CE3-7E363A94B4DA}"/>
+                <a16:creationId xmlns:a16="http://schemas.microsoft.com/office/drawing/2014/main" id="{3F2F896B-4465-9B8B-368F-489C879A61CD}"/>
               </a:ext>
             </a:extLst>
           </p:cNvPr>
@@ -752,7 +747,7 @@
           <a:bodyPr/>
           <a:lstStyle/>
           <a:p>
-            <a:fld id="{3B04DCD2-51FF-4424-A8D0-554917C1B566}" type="datetimeFigureOut">
+            <a:fld id="{248CC083-DEBD-4D69-8B9A-5124E7F9EAC4}" type="datetimeFigureOut">
               <a:rPr lang="en-US" smtClean="0"/>
               <a:t>5/27/2026</a:t>
             </a:fld>
@@ -765,7 +760,7 @@
           <p:cNvPr id="5" name="Footer Placeholder 4">
             <a:extLst>
               <a:ext uri="{FF2B5EF4-FFF2-40B4-BE49-F238E27FC236}">
-                <a16:creationId xmlns:a16="http://schemas.microsoft.com/office/drawing/2014/main" id="{BBA42764-DA31-6A79-AAF3-EFA22C1F3BEA}"/>
+                <a16:creationId xmlns:a16="http://schemas.microsoft.com/office/drawing/2014/main" id="{DD308295-0CEF-D01F-D93F-42540131454D}"/>
               </a:ext>
             </a:extLst>
           </p:cNvPr>
@@ -790,7 +785,7 @@
           <p:cNvPr id="6" name="Slide Number Placeholder 5">
             <a:extLst>
               <a:ext uri="{FF2B5EF4-FFF2-40B4-BE49-F238E27FC236}">
-                <a16:creationId xmlns:a16="http://schemas.microsoft.com/office/drawing/2014/main" id="{A046046A-65CC-0BE0-7350-277F5FD15206}"/>
+                <a16:creationId xmlns:a16="http://schemas.microsoft.com/office/drawing/2014/main" id="{C262C9E7-60C9-AEF4-06AB-1F59DE8837EE}"/>
               </a:ext>
             </a:extLst>
           </p:cNvPr>
@@ -806,7 +801,7 @@
           <a:bodyPr/>
           <a:lstStyle/>
           <a:p>
-            <a:fld id="{AB36B74C-88B0-43C8-957A-2BB332CCF888}" type="slidenum">
+            <a:fld id="{E9775BDE-1FD4-4F3F-94CA-6D2F775373B6}" type="slidenum">
               <a:rPr lang="en-US" smtClean="0"/>
               <a:t>‹#›</a:t>
             </a:fld>
@@ -817,7 +812,7 @@
     </p:spTree>
     <p:extLst>
       <p:ext uri="{BB962C8B-B14F-4D97-AF65-F5344CB8AC3E}">
-        <p14:creationId xmlns:p14="http://schemas.microsoft.com/office/powerpoint/2010/main" val="3157435993"/>
+        <p14:creationId xmlns:p14="http://schemas.microsoft.com/office/powerpoint/2010/main" val="2878456952"/>
       </p:ext>
     </p:extLst>
   </p:cSld>
@@ -849,7 +844,7 @@
           <p:cNvPr id="2" name="Vertical Title 1">
             <a:extLst>
               <a:ext uri="{FF2B5EF4-FFF2-40B4-BE49-F238E27FC236}">
-                <a16:creationId xmlns:a16="http://schemas.microsoft.com/office/drawing/2014/main" id="{744F117A-C5E3-B89C-F131-06B9C9F7CE63}"/>
+                <a16:creationId xmlns:a16="http://schemas.microsoft.com/office/drawing/2014/main" id="{C579848A-5FEF-14B2-C722-F7E93E791FE1}"/>
               </a:ext>
             </a:extLst>
           </p:cNvPr>
@@ -882,7 +877,7 @@
           <p:cNvPr id="3" name="Vertical Text Placeholder 2">
             <a:extLst>
               <a:ext uri="{FF2B5EF4-FFF2-40B4-BE49-F238E27FC236}">
-                <a16:creationId xmlns:a16="http://schemas.microsoft.com/office/drawing/2014/main" id="{F8AE3E4A-625C-1056-7769-ECA765135364}"/>
+                <a16:creationId xmlns:a16="http://schemas.microsoft.com/office/drawing/2014/main" id="{94E626F2-240B-2F70-EABA-8BA6798B4E3B}"/>
               </a:ext>
             </a:extLst>
           </p:cNvPr>
@@ -944,7 +939,7 @@
           <p:cNvPr id="4" name="Date Placeholder 3">
             <a:extLst>
               <a:ext uri="{FF2B5EF4-FFF2-40B4-BE49-F238E27FC236}">
-                <a16:creationId xmlns:a16="http://schemas.microsoft.com/office/drawing/2014/main" id="{4E0B8359-0387-409A-B197-94CCC4B527CB}"/>
+                <a16:creationId xmlns:a16="http://schemas.microsoft.com/office/drawing/2014/main" id="{F8F3A889-F25A-A754-35B5-66308EC81FC3}"/>
               </a:ext>
             </a:extLst>
           </p:cNvPr>
@@ -960,7 +955,7 @@
           <a:bodyPr/>
           <a:lstStyle/>
           <a:p>
-            <a:fld id="{3B04DCD2-51FF-4424-A8D0-554917C1B566}" type="datetimeFigureOut">
+            <a:fld id="{248CC083-DEBD-4D69-8B9A-5124E7F9EAC4}" type="datetimeFigureOut">
               <a:rPr lang="en-US" smtClean="0"/>
               <a:t>5/27/2026</a:t>
             </a:fld>
@@ -973,7 +968,7 @@
           <p:cNvPr id="5" name="Footer Placeholder 4">
             <a:extLst>
               <a:ext uri="{FF2B5EF4-FFF2-40B4-BE49-F238E27FC236}">
-                <a16:creationId xmlns:a16="http://schemas.microsoft.com/office/drawing/2014/main" id="{3E3CEC6D-1AE8-4F08-3208-73B49ACB58E7}"/>
+                <a16:creationId xmlns:a16="http://schemas.microsoft.com/office/drawing/2014/main" id="{1EC43A65-BA7E-5FDB-5DC2-B74B5C108323}"/>
               </a:ext>
             </a:extLst>
           </p:cNvPr>
@@ -998,7 +993,7 @@
           <p:cNvPr id="6" name="Slide Number Placeholder 5">
             <a:extLst>
               <a:ext uri="{FF2B5EF4-FFF2-40B4-BE49-F238E27FC236}">
-                <a16:creationId xmlns:a16="http://schemas.microsoft.com/office/drawing/2014/main" id="{89DE7454-6E70-B5F4-5EAF-CAE6A7D06F68}"/>
+                <a16:creationId xmlns:a16="http://schemas.microsoft.com/office/drawing/2014/main" id="{330F4CF7-4C40-645E-68F5-7ABACEE0873D}"/>
               </a:ext>
             </a:extLst>
           </p:cNvPr>
@@ -1014,7 +1009,7 @@
           <a:bodyPr/>
           <a:lstStyle/>
           <a:p>
-            <a:fld id="{AB36B74C-88B0-43C8-957A-2BB332CCF888}" type="slidenum">
+            <a:fld id="{E9775BDE-1FD4-4F3F-94CA-6D2F775373B6}" type="slidenum">
               <a:rPr lang="en-US" smtClean="0"/>
               <a:t>‹#›</a:t>
             </a:fld>
@@ -1025,7 +1020,7 @@
     </p:spTree>
     <p:extLst>
       <p:ext uri="{BB962C8B-B14F-4D97-AF65-F5344CB8AC3E}">
-        <p14:creationId xmlns:p14="http://schemas.microsoft.com/office/powerpoint/2010/main" val="619837183"/>
+        <p14:creationId xmlns:p14="http://schemas.microsoft.com/office/powerpoint/2010/main" val="1245791120"/>
       </p:ext>
     </p:extLst>
   </p:cSld>
@@ -1057,7 +1052,7 @@
           <p:cNvPr id="2" name="Title 1">
             <a:extLst>
               <a:ext uri="{FF2B5EF4-FFF2-40B4-BE49-F238E27FC236}">
-                <a16:creationId xmlns:a16="http://schemas.microsoft.com/office/drawing/2014/main" id="{FABCE650-2197-00A6-469F-66423AA4010A}"/>
+                <a16:creationId xmlns:a16="http://schemas.microsoft.com/office/drawing/2014/main" id="{3C16CAE3-4E25-88D7-EC27-62372FA801C0}"/>
               </a:ext>
             </a:extLst>
           </p:cNvPr>
@@ -1085,7 +1080,7 @@
           <p:cNvPr id="3" name="Content Placeholder 2">
             <a:extLst>
               <a:ext uri="{FF2B5EF4-FFF2-40B4-BE49-F238E27FC236}">
-                <a16:creationId xmlns:a16="http://schemas.microsoft.com/office/drawing/2014/main" id="{F2109BBB-887F-09FC-A180-0A009289AED0}"/>
+                <a16:creationId xmlns:a16="http://schemas.microsoft.com/office/drawing/2014/main" id="{F9482C91-F644-F169-AA83-E997B99DE8B2}"/>
               </a:ext>
             </a:extLst>
           </p:cNvPr>
@@ -1142,7 +1137,7 @@
           <p:cNvPr id="4" name="Date Placeholder 3">
             <a:extLst>
               <a:ext uri="{FF2B5EF4-FFF2-40B4-BE49-F238E27FC236}">
-                <a16:creationId xmlns:a16="http://schemas.microsoft.com/office/drawing/2014/main" id="{81B47D16-7C35-702B-FCCC-D590A3AFAABD}"/>
+                <a16:creationId xmlns:a16="http://schemas.microsoft.com/office/drawing/2014/main" id="{418ACC6A-B42C-7BF0-54F7-7987E2DBB928}"/>
               </a:ext>
             </a:extLst>
           </p:cNvPr>
@@ -1158,7 +1153,7 @@
           <a:bodyPr/>
           <a:lstStyle/>
           <a:p>
-            <a:fld id="{3B04DCD2-51FF-4424-A8D0-554917C1B566}" type="datetimeFigureOut">
+            <a:fld id="{248CC083-DEBD-4D69-8B9A-5124E7F9EAC4}" type="datetimeFigureOut">
               <a:rPr lang="en-US" smtClean="0"/>
               <a:t>5/27/2026</a:t>
             </a:fld>
@@ -1171,7 +1166,7 @@
           <p:cNvPr id="5" name="Footer Placeholder 4">
             <a:extLst>
               <a:ext uri="{FF2B5EF4-FFF2-40B4-BE49-F238E27FC236}">
-                <a16:creationId xmlns:a16="http://schemas.microsoft.com/office/drawing/2014/main" id="{FBF3B851-5D3F-A2CC-5B49-6C9107334BDC}"/>
+                <a16:creationId xmlns:a16="http://schemas.microsoft.com/office/drawing/2014/main" id="{9625176D-CA8E-665E-E5B1-332814824BAD}"/>
               </a:ext>
             </a:extLst>
           </p:cNvPr>
@@ -1196,7 +1191,7 @@
           <p:cNvPr id="6" name="Slide Number Placeholder 5">
             <a:extLst>
               <a:ext uri="{FF2B5EF4-FFF2-40B4-BE49-F238E27FC236}">
-                <a16:creationId xmlns:a16="http://schemas.microsoft.com/office/drawing/2014/main" id="{1476D9C1-BA80-FC2F-EDCB-52C500DAD901}"/>
+                <a16:creationId xmlns:a16="http://schemas.microsoft.com/office/drawing/2014/main" id="{5CF9A24D-BB9E-7638-4EC8-43C01721590B}"/>
               </a:ext>
             </a:extLst>
           </p:cNvPr>
@@ -1212,7 +1207,7 @@
           <a:bodyPr/>
           <a:lstStyle/>
           <a:p>
-            <a:fld id="{AB36B74C-88B0-43C8-957A-2BB332CCF888}" type="slidenum">
+            <a:fld id="{E9775BDE-1FD4-4F3F-94CA-6D2F775373B6}" type="slidenum">
               <a:rPr lang="en-US" smtClean="0"/>
               <a:t>‹#›</a:t>
             </a:fld>
@@ -1223,7 +1218,7 @@
     </p:spTree>
     <p:extLst>
       <p:ext uri="{BB962C8B-B14F-4D97-AF65-F5344CB8AC3E}">
-        <p14:creationId xmlns:p14="http://schemas.microsoft.com/office/powerpoint/2010/main" val="1385687580"/>
+        <p14:creationId xmlns:p14="http://schemas.microsoft.com/office/powerpoint/2010/main" val="1400340339"/>
       </p:ext>
     </p:extLst>
   </p:cSld>
@@ -1255,7 +1250,7 @@
           <p:cNvPr id="2" name="Title 1">
             <a:extLst>
               <a:ext uri="{FF2B5EF4-FFF2-40B4-BE49-F238E27FC236}">
-                <a16:creationId xmlns:a16="http://schemas.microsoft.com/office/drawing/2014/main" id="{051AC5FA-8FE9-0171-4C7F-8430BCB7C0DE}"/>
+                <a16:creationId xmlns:a16="http://schemas.microsoft.com/office/drawing/2014/main" id="{E7FE00FB-84EB-6AF3-1548-4C7D6BEA1F80}"/>
               </a:ext>
             </a:extLst>
           </p:cNvPr>
@@ -1292,7 +1287,7 @@
           <p:cNvPr id="3" name="Text Placeholder 2">
             <a:extLst>
               <a:ext uri="{FF2B5EF4-FFF2-40B4-BE49-F238E27FC236}">
-                <a16:creationId xmlns:a16="http://schemas.microsoft.com/office/drawing/2014/main" id="{792B8CAE-272D-6BE6-F4A6-DD4D19FD044E}"/>
+                <a16:creationId xmlns:a16="http://schemas.microsoft.com/office/drawing/2014/main" id="{731ECBF5-3FD3-347A-DDDD-7B773B0D20DC}"/>
               </a:ext>
             </a:extLst>
           </p:cNvPr>
@@ -1417,7 +1412,7 @@
           <p:cNvPr id="4" name="Date Placeholder 3">
             <a:extLst>
               <a:ext uri="{FF2B5EF4-FFF2-40B4-BE49-F238E27FC236}">
-                <a16:creationId xmlns:a16="http://schemas.microsoft.com/office/drawing/2014/main" id="{7CA817AF-B8A6-ABDE-812F-26087D92649B}"/>
+                <a16:creationId xmlns:a16="http://schemas.microsoft.com/office/drawing/2014/main" id="{F9866761-2A63-0E3E-7966-618F7CFC7244}"/>
               </a:ext>
             </a:extLst>
           </p:cNvPr>
@@ -1433,7 +1428,7 @@
           <a:bodyPr/>
           <a:lstStyle/>
           <a:p>
-            <a:fld id="{3B04DCD2-51FF-4424-A8D0-554917C1B566}" type="datetimeFigureOut">
+            <a:fld id="{248CC083-DEBD-4D69-8B9A-5124E7F9EAC4}" type="datetimeFigureOut">
               <a:rPr lang="en-US" smtClean="0"/>
               <a:t>5/27/2026</a:t>
             </a:fld>
@@ -1446,7 +1441,7 @@
           <p:cNvPr id="5" name="Footer Placeholder 4">
             <a:extLst>
               <a:ext uri="{FF2B5EF4-FFF2-40B4-BE49-F238E27FC236}">
-                <a16:creationId xmlns:a16="http://schemas.microsoft.com/office/drawing/2014/main" id="{3CD163E1-7AF5-961D-E33D-569DB656556E}"/>
+                <a16:creationId xmlns:a16="http://schemas.microsoft.com/office/drawing/2014/main" id="{DFE8347D-90A5-0814-A034-19562B694406}"/>
               </a:ext>
             </a:extLst>
           </p:cNvPr>
@@ -1471,7 +1466,7 @@
           <p:cNvPr id="6" name="Slide Number Placeholder 5">
             <a:extLst>
               <a:ext uri="{FF2B5EF4-FFF2-40B4-BE49-F238E27FC236}">
-                <a16:creationId xmlns:a16="http://schemas.microsoft.com/office/drawing/2014/main" id="{D79B04C5-4BED-49AA-5C33-7D98355AD485}"/>
+                <a16:creationId xmlns:a16="http://schemas.microsoft.com/office/drawing/2014/main" id="{54D20EC0-BC83-7B04-9E86-5BB003144D3E}"/>
               </a:ext>
             </a:extLst>
           </p:cNvPr>
@@ -1487,7 +1482,7 @@
           <a:bodyPr/>
           <a:lstStyle/>
           <a:p>
-            <a:fld id="{AB36B74C-88B0-43C8-957A-2BB332CCF888}" type="slidenum">
+            <a:fld id="{E9775BDE-1FD4-4F3F-94CA-6D2F775373B6}" type="slidenum">
               <a:rPr lang="en-US" smtClean="0"/>
               <a:t>‹#›</a:t>
             </a:fld>
@@ -1498,7 +1493,7 @@
     </p:spTree>
     <p:extLst>
       <p:ext uri="{BB962C8B-B14F-4D97-AF65-F5344CB8AC3E}">
-        <p14:creationId xmlns:p14="http://schemas.microsoft.com/office/powerpoint/2010/main" val="2254276119"/>
+        <p14:creationId xmlns:p14="http://schemas.microsoft.com/office/powerpoint/2010/main" val="3097463949"/>
       </p:ext>
     </p:extLst>
   </p:cSld>
@@ -1530,7 +1525,7 @@
           <p:cNvPr id="2" name="Title 1">
             <a:extLst>
               <a:ext uri="{FF2B5EF4-FFF2-40B4-BE49-F238E27FC236}">
-                <a16:creationId xmlns:a16="http://schemas.microsoft.com/office/drawing/2014/main" id="{265D2CA4-A2FC-FE30-453B-24B32C27EC2C}"/>
+                <a16:creationId xmlns:a16="http://schemas.microsoft.com/office/drawing/2014/main" id="{D06FB3AB-D602-EE99-4E59-584E74CE8C7B}"/>
               </a:ext>
             </a:extLst>
           </p:cNvPr>
@@ -1558,7 +1553,7 @@
           <p:cNvPr id="3" name="Content Placeholder 2">
             <a:extLst>
               <a:ext uri="{FF2B5EF4-FFF2-40B4-BE49-F238E27FC236}">
-                <a16:creationId xmlns:a16="http://schemas.microsoft.com/office/drawing/2014/main" id="{18FB3DAF-5148-3D4E-0810-50B862A1CF3D}"/>
+                <a16:creationId xmlns:a16="http://schemas.microsoft.com/office/drawing/2014/main" id="{C4F8BD2E-A46C-B424-7D1B-1D43BD67199A}"/>
               </a:ext>
             </a:extLst>
           </p:cNvPr>
@@ -1620,7 +1615,7 @@
           <p:cNvPr id="4" name="Content Placeholder 3">
             <a:extLst>
               <a:ext uri="{FF2B5EF4-FFF2-40B4-BE49-F238E27FC236}">
-                <a16:creationId xmlns:a16="http://schemas.microsoft.com/office/drawing/2014/main" id="{05F12D36-7E02-3ABA-44D2-32E44FD18C7D}"/>
+                <a16:creationId xmlns:a16="http://schemas.microsoft.com/office/drawing/2014/main" id="{46B925E8-705A-3FFB-00AD-A085BECCC2B2}"/>
               </a:ext>
             </a:extLst>
           </p:cNvPr>
@@ -1682,7 +1677,7 @@
           <p:cNvPr id="5" name="Date Placeholder 4">
             <a:extLst>
               <a:ext uri="{FF2B5EF4-FFF2-40B4-BE49-F238E27FC236}">
-                <a16:creationId xmlns:a16="http://schemas.microsoft.com/office/drawing/2014/main" id="{54E83DB8-9399-A200-155E-FAE1C72D23F3}"/>
+                <a16:creationId xmlns:a16="http://schemas.microsoft.com/office/drawing/2014/main" id="{8A39F4BC-A870-0534-AAC4-17772BABCCDB}"/>
               </a:ext>
             </a:extLst>
           </p:cNvPr>
@@ -1698,7 +1693,7 @@
           <a:bodyPr/>
           <a:lstStyle/>
           <a:p>
-            <a:fld id="{3B04DCD2-51FF-4424-A8D0-554917C1B566}" type="datetimeFigureOut">
+            <a:fld id="{248CC083-DEBD-4D69-8B9A-5124E7F9EAC4}" type="datetimeFigureOut">
               <a:rPr lang="en-US" smtClean="0"/>
               <a:t>5/27/2026</a:t>
             </a:fld>
@@ -1711,7 +1706,7 @@
           <p:cNvPr id="6" name="Footer Placeholder 5">
             <a:extLst>
               <a:ext uri="{FF2B5EF4-FFF2-40B4-BE49-F238E27FC236}">
-                <a16:creationId xmlns:a16="http://schemas.microsoft.com/office/drawing/2014/main" id="{D3C66257-9990-DEC4-E54E-4CDE3C90DEDB}"/>
+                <a16:creationId xmlns:a16="http://schemas.microsoft.com/office/drawing/2014/main" id="{B6182568-B095-3C4B-8160-974B1A8560F1}"/>
               </a:ext>
             </a:extLst>
           </p:cNvPr>
@@ -1736,7 +1731,7 @@
           <p:cNvPr id="7" name="Slide Number Placeholder 6">
             <a:extLst>
               <a:ext uri="{FF2B5EF4-FFF2-40B4-BE49-F238E27FC236}">
-                <a16:creationId xmlns:a16="http://schemas.microsoft.com/office/drawing/2014/main" id="{025E3224-F42B-E56D-67F5-21997BB8E02E}"/>
+                <a16:creationId xmlns:a16="http://schemas.microsoft.com/office/drawing/2014/main" id="{7A4F04A2-D7D9-6E2F-54A5-25E3C7B50ED0}"/>
               </a:ext>
             </a:extLst>
           </p:cNvPr>
@@ -1752,7 +1747,7 @@
           <a:bodyPr/>
           <a:lstStyle/>
           <a:p>
-            <a:fld id="{AB36B74C-88B0-43C8-957A-2BB332CCF888}" type="slidenum">
+            <a:fld id="{E9775BDE-1FD4-4F3F-94CA-6D2F775373B6}" type="slidenum">
               <a:rPr lang="en-US" smtClean="0"/>
               <a:t>‹#›</a:t>
             </a:fld>
@@ -1763,7 +1758,7 @@
     </p:spTree>
     <p:extLst>
       <p:ext uri="{BB962C8B-B14F-4D97-AF65-F5344CB8AC3E}">
-        <p14:creationId xmlns:p14="http://schemas.microsoft.com/office/powerpoint/2010/main" val="3161747405"/>
+        <p14:creationId xmlns:p14="http://schemas.microsoft.com/office/powerpoint/2010/main" val="2795753603"/>
       </p:ext>
     </p:extLst>
   </p:cSld>
@@ -1795,7 +1790,7 @@
           <p:cNvPr id="2" name="Title 1">
             <a:extLst>
               <a:ext uri="{FF2B5EF4-FFF2-40B4-BE49-F238E27FC236}">
-                <a16:creationId xmlns:a16="http://schemas.microsoft.com/office/drawing/2014/main" id="{9B86A0C2-A78D-D77E-7EAA-14BF019BB1EE}"/>
+                <a16:creationId xmlns:a16="http://schemas.microsoft.com/office/drawing/2014/main" id="{5F6A3EA1-EE60-D67B-5695-CD83F3BB851C}"/>
               </a:ext>
             </a:extLst>
           </p:cNvPr>
@@ -1828,7 +1823,7 @@
           <p:cNvPr id="3" name="Text Placeholder 2">
             <a:extLst>
               <a:ext uri="{FF2B5EF4-FFF2-40B4-BE49-F238E27FC236}">
-                <a16:creationId xmlns:a16="http://schemas.microsoft.com/office/drawing/2014/main" id="{2DF8AEDE-494C-CE4B-A4C0-DBD9BF04DFB4}"/>
+                <a16:creationId xmlns:a16="http://schemas.microsoft.com/office/drawing/2014/main" id="{A2875630-9FF9-45A1-4D5E-C3C86C21658B}"/>
               </a:ext>
             </a:extLst>
           </p:cNvPr>
@@ -1899,7 +1894,7 @@
           <p:cNvPr id="4" name="Content Placeholder 3">
             <a:extLst>
               <a:ext uri="{FF2B5EF4-FFF2-40B4-BE49-F238E27FC236}">
-                <a16:creationId xmlns:a16="http://schemas.microsoft.com/office/drawing/2014/main" id="{1ACDC1F6-44BF-3CAB-7EE3-121D217A2B6E}"/>
+                <a16:creationId xmlns:a16="http://schemas.microsoft.com/office/drawing/2014/main" id="{73E4C741-18B0-05E2-DA47-D1F20B18C9C7}"/>
               </a:ext>
             </a:extLst>
           </p:cNvPr>
@@ -1961,7 +1956,7 @@
           <p:cNvPr id="5" name="Text Placeholder 4">
             <a:extLst>
               <a:ext uri="{FF2B5EF4-FFF2-40B4-BE49-F238E27FC236}">
-                <a16:creationId xmlns:a16="http://schemas.microsoft.com/office/drawing/2014/main" id="{E5285E3F-000C-D113-E500-BF92270F26EE}"/>
+                <a16:creationId xmlns:a16="http://schemas.microsoft.com/office/drawing/2014/main" id="{0863B32A-0AD8-97EB-90CB-F55B5E6491F8}"/>
               </a:ext>
             </a:extLst>
           </p:cNvPr>
@@ -2032,7 +2027,7 @@
           <p:cNvPr id="6" name="Content Placeholder 5">
             <a:extLst>
               <a:ext uri="{FF2B5EF4-FFF2-40B4-BE49-F238E27FC236}">
-                <a16:creationId xmlns:a16="http://schemas.microsoft.com/office/drawing/2014/main" id="{0F5CDE75-D880-7459-043F-9CC301DB3888}"/>
+                <a16:creationId xmlns:a16="http://schemas.microsoft.com/office/drawing/2014/main" id="{A58A030B-8AA2-11DB-CD7C-63509511BA6F}"/>
               </a:ext>
             </a:extLst>
           </p:cNvPr>
@@ -2094,7 +2089,7 @@
           <p:cNvPr id="7" name="Date Placeholder 6">
             <a:extLst>
               <a:ext uri="{FF2B5EF4-FFF2-40B4-BE49-F238E27FC236}">
-                <a16:creationId xmlns:a16="http://schemas.microsoft.com/office/drawing/2014/main" id="{4458CDCA-C1A3-176C-ABFA-850298566AB7}"/>
+                <a16:creationId xmlns:a16="http://schemas.microsoft.com/office/drawing/2014/main" id="{849FA31C-46F8-42BC-7A23-74123F1FDCC1}"/>
               </a:ext>
             </a:extLst>
           </p:cNvPr>
@@ -2110,7 +2105,7 @@
           <a:bodyPr/>
           <a:lstStyle/>
           <a:p>
-            <a:fld id="{3B04DCD2-51FF-4424-A8D0-554917C1B566}" type="datetimeFigureOut">
+            <a:fld id="{248CC083-DEBD-4D69-8B9A-5124E7F9EAC4}" type="datetimeFigureOut">
               <a:rPr lang="en-US" smtClean="0"/>
               <a:t>5/27/2026</a:t>
             </a:fld>
@@ -2123,7 +2118,7 @@
           <p:cNvPr id="8" name="Footer Placeholder 7">
             <a:extLst>
               <a:ext uri="{FF2B5EF4-FFF2-40B4-BE49-F238E27FC236}">
-                <a16:creationId xmlns:a16="http://schemas.microsoft.com/office/drawing/2014/main" id="{9754042D-1C6B-D7B6-F45E-72A0020291F6}"/>
+                <a16:creationId xmlns:a16="http://schemas.microsoft.com/office/drawing/2014/main" id="{8A0B52AA-B073-2F81-E5F7-E2DB69B0B718}"/>
               </a:ext>
             </a:extLst>
           </p:cNvPr>
@@ -2148,7 +2143,7 @@
           <p:cNvPr id="9" name="Slide Number Placeholder 8">
             <a:extLst>
               <a:ext uri="{FF2B5EF4-FFF2-40B4-BE49-F238E27FC236}">
-                <a16:creationId xmlns:a16="http://schemas.microsoft.com/office/drawing/2014/main" id="{D37A01D6-AAE5-1FA6-389A-B9F4B32E26E9}"/>
+                <a16:creationId xmlns:a16="http://schemas.microsoft.com/office/drawing/2014/main" id="{1E92EE7B-60E6-FA98-B95C-43BC7FE647D9}"/>
               </a:ext>
             </a:extLst>
           </p:cNvPr>
@@ -2164,7 +2159,7 @@
           <a:bodyPr/>
           <a:lstStyle/>
           <a:p>
-            <a:fld id="{AB36B74C-88B0-43C8-957A-2BB332CCF888}" type="slidenum">
+            <a:fld id="{E9775BDE-1FD4-4F3F-94CA-6D2F775373B6}" type="slidenum">
               <a:rPr lang="en-US" smtClean="0"/>
               <a:t>‹#›</a:t>
             </a:fld>
@@ -2175,7 +2170,7 @@
     </p:spTree>
     <p:extLst>
       <p:ext uri="{BB962C8B-B14F-4D97-AF65-F5344CB8AC3E}">
-        <p14:creationId xmlns:p14="http://schemas.microsoft.com/office/powerpoint/2010/main" val="1636585996"/>
+        <p14:creationId xmlns:p14="http://schemas.microsoft.com/office/powerpoint/2010/main" val="4180332402"/>
       </p:ext>
     </p:extLst>
   </p:cSld>
@@ -2207,7 +2202,7 @@
           <p:cNvPr id="2" name="Title 1">
             <a:extLst>
               <a:ext uri="{FF2B5EF4-FFF2-40B4-BE49-F238E27FC236}">
-                <a16:creationId xmlns:a16="http://schemas.microsoft.com/office/drawing/2014/main" id="{32B4A2D6-47D6-8AF9-EA4C-06442DD3375E}"/>
+                <a16:creationId xmlns:a16="http://schemas.microsoft.com/office/drawing/2014/main" id="{23BEB5AE-B86B-FA5D-3030-EE0C2840447F}"/>
               </a:ext>
             </a:extLst>
           </p:cNvPr>
@@ -2235,7 +2230,7 @@
           <p:cNvPr id="3" name="Date Placeholder 2">
             <a:extLst>
               <a:ext uri="{FF2B5EF4-FFF2-40B4-BE49-F238E27FC236}">
-                <a16:creationId xmlns:a16="http://schemas.microsoft.com/office/drawing/2014/main" id="{8FCA8D79-E2A2-E931-2BE1-365EDEBBFF7C}"/>
+                <a16:creationId xmlns:a16="http://schemas.microsoft.com/office/drawing/2014/main" id="{1BD82C10-6F70-DF11-9999-836C911E378F}"/>
               </a:ext>
             </a:extLst>
           </p:cNvPr>
@@ -2251,7 +2246,7 @@
           <a:bodyPr/>
           <a:lstStyle/>
           <a:p>
-            <a:fld id="{3B04DCD2-51FF-4424-A8D0-554917C1B566}" type="datetimeFigureOut">
+            <a:fld id="{248CC083-DEBD-4D69-8B9A-5124E7F9EAC4}" type="datetimeFigureOut">
               <a:rPr lang="en-US" smtClean="0"/>
               <a:t>5/27/2026</a:t>
             </a:fld>
@@ -2264,7 +2259,7 @@
           <p:cNvPr id="4" name="Footer Placeholder 3">
             <a:extLst>
               <a:ext uri="{FF2B5EF4-FFF2-40B4-BE49-F238E27FC236}">
-                <a16:creationId xmlns:a16="http://schemas.microsoft.com/office/drawing/2014/main" id="{2B7A6946-72C1-323A-1BA6-945C94703178}"/>
+                <a16:creationId xmlns:a16="http://schemas.microsoft.com/office/drawing/2014/main" id="{02A23FF8-8097-C796-C576-14E695FED5CA}"/>
               </a:ext>
             </a:extLst>
           </p:cNvPr>
@@ -2289,7 +2284,7 @@
           <p:cNvPr id="5" name="Slide Number Placeholder 4">
             <a:extLst>
               <a:ext uri="{FF2B5EF4-FFF2-40B4-BE49-F238E27FC236}">
-                <a16:creationId xmlns:a16="http://schemas.microsoft.com/office/drawing/2014/main" id="{E28B7783-1403-04A9-33A0-C0132E45C314}"/>
+                <a16:creationId xmlns:a16="http://schemas.microsoft.com/office/drawing/2014/main" id="{D0D269F2-71FD-C060-F442-7FFA552F581C}"/>
               </a:ext>
             </a:extLst>
           </p:cNvPr>
@@ -2305,7 +2300,7 @@
           <a:bodyPr/>
           <a:lstStyle/>
           <a:p>
-            <a:fld id="{AB36B74C-88B0-43C8-957A-2BB332CCF888}" type="slidenum">
+            <a:fld id="{E9775BDE-1FD4-4F3F-94CA-6D2F775373B6}" type="slidenum">
               <a:rPr lang="en-US" smtClean="0"/>
               <a:t>‹#›</a:t>
             </a:fld>
@@ -2316,7 +2311,7 @@
     </p:spTree>
     <p:extLst>
       <p:ext uri="{BB962C8B-B14F-4D97-AF65-F5344CB8AC3E}">
-        <p14:creationId xmlns:p14="http://schemas.microsoft.com/office/powerpoint/2010/main" val="3093300996"/>
+        <p14:creationId xmlns:p14="http://schemas.microsoft.com/office/powerpoint/2010/main" val="2415009768"/>
       </p:ext>
     </p:extLst>
   </p:cSld>
@@ -2348,7 +2343,7 @@
           <p:cNvPr id="2" name="Date Placeholder 1">
             <a:extLst>
               <a:ext uri="{FF2B5EF4-FFF2-40B4-BE49-F238E27FC236}">
-                <a16:creationId xmlns:a16="http://schemas.microsoft.com/office/drawing/2014/main" id="{8AD93316-7C2D-4136-8196-70541135E704}"/>
+                <a16:creationId xmlns:a16="http://schemas.microsoft.com/office/drawing/2014/main" id="{C88560A0-2552-CBAF-19AD-D5B73719AE46}"/>
               </a:ext>
             </a:extLst>
           </p:cNvPr>
@@ -2364,7 +2359,7 @@
           <a:bodyPr/>
           <a:lstStyle/>
           <a:p>
-            <a:fld id="{3B04DCD2-51FF-4424-A8D0-554917C1B566}" type="datetimeFigureOut">
+            <a:fld id="{248CC083-DEBD-4D69-8B9A-5124E7F9EAC4}" type="datetimeFigureOut">
               <a:rPr lang="en-US" smtClean="0"/>
               <a:t>5/27/2026</a:t>
             </a:fld>
@@ -2377,7 +2372,7 @@
           <p:cNvPr id="3" name="Footer Placeholder 2">
             <a:extLst>
               <a:ext uri="{FF2B5EF4-FFF2-40B4-BE49-F238E27FC236}">
-                <a16:creationId xmlns:a16="http://schemas.microsoft.com/office/drawing/2014/main" id="{982ECF52-2C88-2E3F-BEBC-D38B42ECE646}"/>
+                <a16:creationId xmlns:a16="http://schemas.microsoft.com/office/drawing/2014/main" id="{B35CC65E-EC2D-564F-F665-6D549C91BC4C}"/>
               </a:ext>
             </a:extLst>
           </p:cNvPr>
@@ -2402,7 +2397,7 @@
           <p:cNvPr id="4" name="Slide Number Placeholder 3">
             <a:extLst>
               <a:ext uri="{FF2B5EF4-FFF2-40B4-BE49-F238E27FC236}">
-                <a16:creationId xmlns:a16="http://schemas.microsoft.com/office/drawing/2014/main" id="{C1D7C7CC-AABF-48FE-69AC-39EEA7260F9F}"/>
+                <a16:creationId xmlns:a16="http://schemas.microsoft.com/office/drawing/2014/main" id="{73D3685D-2DB5-6B5D-31D9-F15A81EBF605}"/>
               </a:ext>
             </a:extLst>
           </p:cNvPr>
@@ -2418,7 +2413,7 @@
           <a:bodyPr/>
           <a:lstStyle/>
           <a:p>
-            <a:fld id="{AB36B74C-88B0-43C8-957A-2BB332CCF888}" type="slidenum">
+            <a:fld id="{E9775BDE-1FD4-4F3F-94CA-6D2F775373B6}" type="slidenum">
               <a:rPr lang="en-US" smtClean="0"/>
               <a:t>‹#›</a:t>
             </a:fld>
@@ -2429,7 +2424,7 @@
     </p:spTree>
     <p:extLst>
       <p:ext uri="{BB962C8B-B14F-4D97-AF65-F5344CB8AC3E}">
-        <p14:creationId xmlns:p14="http://schemas.microsoft.com/office/powerpoint/2010/main" val="1716825024"/>
+        <p14:creationId xmlns:p14="http://schemas.microsoft.com/office/powerpoint/2010/main" val="3032438483"/>
       </p:ext>
     </p:extLst>
   </p:cSld>
@@ -2461,7 +2456,7 @@
           <p:cNvPr id="2" name="Title 1">
             <a:extLst>
               <a:ext uri="{FF2B5EF4-FFF2-40B4-BE49-F238E27FC236}">
-                <a16:creationId xmlns:a16="http://schemas.microsoft.com/office/drawing/2014/main" id="{BF948953-A100-8F69-4F77-E360A32630AE}"/>
+                <a16:creationId xmlns:a16="http://schemas.microsoft.com/office/drawing/2014/main" id="{77DA2017-71D8-AF44-6812-53A4512B7B30}"/>
               </a:ext>
             </a:extLst>
           </p:cNvPr>
@@ -2498,7 +2493,7 @@
           <p:cNvPr id="3" name="Content Placeholder 2">
             <a:extLst>
               <a:ext uri="{FF2B5EF4-FFF2-40B4-BE49-F238E27FC236}">
-                <a16:creationId xmlns:a16="http://schemas.microsoft.com/office/drawing/2014/main" id="{B6311BBF-DC1B-07AD-DF4F-FF125C81CCC3}"/>
+                <a16:creationId xmlns:a16="http://schemas.microsoft.com/office/drawing/2014/main" id="{B2EDC85B-5879-FA5F-01F2-48C31F9CBE3D}"/>
               </a:ext>
             </a:extLst>
           </p:cNvPr>
@@ -2588,7 +2583,7 @@
           <p:cNvPr id="4" name="Text Placeholder 3">
             <a:extLst>
               <a:ext uri="{FF2B5EF4-FFF2-40B4-BE49-F238E27FC236}">
-                <a16:creationId xmlns:a16="http://schemas.microsoft.com/office/drawing/2014/main" id="{60B70BC2-6166-8C4C-9080-AAF595295209}"/>
+                <a16:creationId xmlns:a16="http://schemas.microsoft.com/office/drawing/2014/main" id="{9FB14E31-8E1C-AA29-278A-5CB46044815A}"/>
               </a:ext>
             </a:extLst>
           </p:cNvPr>
@@ -2659,7 +2654,7 @@
           <p:cNvPr id="5" name="Date Placeholder 4">
             <a:extLst>
               <a:ext uri="{FF2B5EF4-FFF2-40B4-BE49-F238E27FC236}">
-                <a16:creationId xmlns:a16="http://schemas.microsoft.com/office/drawing/2014/main" id="{6AEB6D0D-AA68-D8D2-31AC-4C1BDFB00F24}"/>
+                <a16:creationId xmlns:a16="http://schemas.microsoft.com/office/drawing/2014/main" id="{74E68DF9-30B3-B8CA-6509-D7A4FC5F0417}"/>
               </a:ext>
             </a:extLst>
           </p:cNvPr>
@@ -2675,7 +2670,7 @@
           <a:bodyPr/>
           <a:lstStyle/>
           <a:p>
-            <a:fld id="{3B04DCD2-51FF-4424-A8D0-554917C1B566}" type="datetimeFigureOut">
+            <a:fld id="{248CC083-DEBD-4D69-8B9A-5124E7F9EAC4}" type="datetimeFigureOut">
               <a:rPr lang="en-US" smtClean="0"/>
               <a:t>5/27/2026</a:t>
             </a:fld>
@@ -2688,7 +2683,7 @@
           <p:cNvPr id="6" name="Footer Placeholder 5">
             <a:extLst>
               <a:ext uri="{FF2B5EF4-FFF2-40B4-BE49-F238E27FC236}">
-                <a16:creationId xmlns:a16="http://schemas.microsoft.com/office/drawing/2014/main" id="{D31D8D37-423D-4061-2A0F-1783A2C11963}"/>
+                <a16:creationId xmlns:a16="http://schemas.microsoft.com/office/drawing/2014/main" id="{C89C4312-09F8-BF52-DD7C-20D288E82093}"/>
               </a:ext>
             </a:extLst>
           </p:cNvPr>
@@ -2713,7 +2708,7 @@
           <p:cNvPr id="7" name="Slide Number Placeholder 6">
             <a:extLst>
               <a:ext uri="{FF2B5EF4-FFF2-40B4-BE49-F238E27FC236}">
-                <a16:creationId xmlns:a16="http://schemas.microsoft.com/office/drawing/2014/main" id="{AF94B4E3-4981-F7CC-5443-66C7BC9B260E}"/>
+                <a16:creationId xmlns:a16="http://schemas.microsoft.com/office/drawing/2014/main" id="{01F589C9-711C-0098-1BD1-FDCAF46BAF2D}"/>
               </a:ext>
             </a:extLst>
           </p:cNvPr>
@@ -2729,7 +2724,7 @@
           <a:bodyPr/>
           <a:lstStyle/>
           <a:p>
-            <a:fld id="{AB36B74C-88B0-43C8-957A-2BB332CCF888}" type="slidenum">
+            <a:fld id="{E9775BDE-1FD4-4F3F-94CA-6D2F775373B6}" type="slidenum">
               <a:rPr lang="en-US" smtClean="0"/>
               <a:t>‹#›</a:t>
             </a:fld>
@@ -2740,7 +2735,7 @@
     </p:spTree>
     <p:extLst>
       <p:ext uri="{BB962C8B-B14F-4D97-AF65-F5344CB8AC3E}">
-        <p14:creationId xmlns:p14="http://schemas.microsoft.com/office/powerpoint/2010/main" val="658799276"/>
+        <p14:creationId xmlns:p14="http://schemas.microsoft.com/office/powerpoint/2010/main" val="1968859816"/>
       </p:ext>
     </p:extLst>
   </p:cSld>
@@ -2772,7 +2767,7 @@
           <p:cNvPr id="2" name="Title 1">
             <a:extLst>
               <a:ext uri="{FF2B5EF4-FFF2-40B4-BE49-F238E27FC236}">
-                <a16:creationId xmlns:a16="http://schemas.microsoft.com/office/drawing/2014/main" id="{FE9F0C86-601D-C760-F64C-7CC8EFB3DED7}"/>
+                <a16:creationId xmlns:a16="http://schemas.microsoft.com/office/drawing/2014/main" id="{2C2C1E30-4C37-652B-3D9F-B7163BC44465}"/>
               </a:ext>
             </a:extLst>
           </p:cNvPr>
@@ -2809,7 +2804,7 @@
           <p:cNvPr id="3" name="Picture Placeholder 2">
             <a:extLst>
               <a:ext uri="{FF2B5EF4-FFF2-40B4-BE49-F238E27FC236}">
-                <a16:creationId xmlns:a16="http://schemas.microsoft.com/office/drawing/2014/main" id="{17716703-DCAD-C3FD-5682-E6228FBA907B}"/>
+                <a16:creationId xmlns:a16="http://schemas.microsoft.com/office/drawing/2014/main" id="{C5BAAB24-444A-6278-1070-EA46A93B44AD}"/>
               </a:ext>
             </a:extLst>
           </p:cNvPr>
@@ -2876,7 +2871,7 @@
           <p:cNvPr id="4" name="Text Placeholder 3">
             <a:extLst>
               <a:ext uri="{FF2B5EF4-FFF2-40B4-BE49-F238E27FC236}">
-                <a16:creationId xmlns:a16="http://schemas.microsoft.com/office/drawing/2014/main" id="{CB7CA4F8-8DEA-881D-1E86-6DC191CEB3C8}"/>
+                <a16:creationId xmlns:a16="http://schemas.microsoft.com/office/drawing/2014/main" id="{180AD310-C427-82E4-C419-3BA5288F993F}"/>
               </a:ext>
             </a:extLst>
           </p:cNvPr>
@@ -2947,7 +2942,7 @@
           <p:cNvPr id="5" name="Date Placeholder 4">
             <a:extLst>
               <a:ext uri="{FF2B5EF4-FFF2-40B4-BE49-F238E27FC236}">
-                <a16:creationId xmlns:a16="http://schemas.microsoft.com/office/drawing/2014/main" id="{E220FF17-8DB3-F8E3-B440-8060122D3010}"/>
+                <a16:creationId xmlns:a16="http://schemas.microsoft.com/office/drawing/2014/main" id="{99C45D00-927A-90A1-6F0E-DE9BD0C28D02}"/>
               </a:ext>
             </a:extLst>
           </p:cNvPr>
@@ -2963,7 +2958,7 @@
           <a:bodyPr/>
           <a:lstStyle/>
           <a:p>
-            <a:fld id="{3B04DCD2-51FF-4424-A8D0-554917C1B566}" type="datetimeFigureOut">
+            <a:fld id="{248CC083-DEBD-4D69-8B9A-5124E7F9EAC4}" type="datetimeFigureOut">
               <a:rPr lang="en-US" smtClean="0"/>
               <a:t>5/27/2026</a:t>
             </a:fld>
@@ -2976,7 +2971,7 @@
           <p:cNvPr id="6" name="Footer Placeholder 5">
             <a:extLst>
               <a:ext uri="{FF2B5EF4-FFF2-40B4-BE49-F238E27FC236}">
-                <a16:creationId xmlns:a16="http://schemas.microsoft.com/office/drawing/2014/main" id="{61234EE8-1CD1-4D65-5B48-51952BAB472A}"/>
+                <a16:creationId xmlns:a16="http://schemas.microsoft.com/office/drawing/2014/main" id="{808ED55E-6BCB-4BB6-087B-39BFE6C4EA6E}"/>
               </a:ext>
             </a:extLst>
           </p:cNvPr>
@@ -3001,7 +2996,7 @@
           <p:cNvPr id="7" name="Slide Number Placeholder 6">
             <a:extLst>
               <a:ext uri="{FF2B5EF4-FFF2-40B4-BE49-F238E27FC236}">
-                <a16:creationId xmlns:a16="http://schemas.microsoft.com/office/drawing/2014/main" id="{62FDF4B3-EBAF-2C2B-8812-69BBF47418CE}"/>
+                <a16:creationId xmlns:a16="http://schemas.microsoft.com/office/drawing/2014/main" id="{77E2125A-9B45-4124-9084-28166FC02A0F}"/>
               </a:ext>
             </a:extLst>
           </p:cNvPr>
@@ -3017,7 +3012,7 @@
           <a:bodyPr/>
           <a:lstStyle/>
           <a:p>
-            <a:fld id="{AB36B74C-88B0-43C8-957A-2BB332CCF888}" type="slidenum">
+            <a:fld id="{E9775BDE-1FD4-4F3F-94CA-6D2F775373B6}" type="slidenum">
               <a:rPr lang="en-US" smtClean="0"/>
               <a:t>‹#›</a:t>
             </a:fld>
@@ -3028,7 +3023,7 @@
     </p:spTree>
     <p:extLst>
       <p:ext uri="{BB962C8B-B14F-4D97-AF65-F5344CB8AC3E}">
-        <p14:creationId xmlns:p14="http://schemas.microsoft.com/office/powerpoint/2010/main" val="443600406"/>
+        <p14:creationId xmlns:p14="http://schemas.microsoft.com/office/powerpoint/2010/main" val="2746024513"/>
       </p:ext>
     </p:extLst>
   </p:cSld>
@@ -3065,7 +3060,7 @@
           <p:cNvPr id="2" name="Title Placeholder 1">
             <a:extLst>
               <a:ext uri="{FF2B5EF4-FFF2-40B4-BE49-F238E27FC236}">
-                <a16:creationId xmlns:a16="http://schemas.microsoft.com/office/drawing/2014/main" id="{A6678519-1D24-DE8E-1C0C-E7B71F0CEA6F}"/>
+                <a16:creationId xmlns:a16="http://schemas.microsoft.com/office/drawing/2014/main" id="{978EF4D6-98FB-5E2E-E082-C6318E7A7442}"/>
               </a:ext>
             </a:extLst>
           </p:cNvPr>
@@ -3103,7 +3098,7 @@
           <p:cNvPr id="3" name="Text Placeholder 2">
             <a:extLst>
               <a:ext uri="{FF2B5EF4-FFF2-40B4-BE49-F238E27FC236}">
-                <a16:creationId xmlns:a16="http://schemas.microsoft.com/office/drawing/2014/main" id="{F21B958B-6C88-54F5-9A3B-7AD2986D288C}"/>
+                <a16:creationId xmlns:a16="http://schemas.microsoft.com/office/drawing/2014/main" id="{3574DCE3-00EB-5AFF-4494-25BC9BBD2710}"/>
               </a:ext>
             </a:extLst>
           </p:cNvPr>
@@ -3170,7 +3165,7 @@
           <p:cNvPr id="4" name="Date Placeholder 3">
             <a:extLst>
               <a:ext uri="{FF2B5EF4-FFF2-40B4-BE49-F238E27FC236}">
-                <a16:creationId xmlns:a16="http://schemas.microsoft.com/office/drawing/2014/main" id="{B9280330-2808-9D6F-10A3-64134EE32191}"/>
+                <a16:creationId xmlns:a16="http://schemas.microsoft.com/office/drawing/2014/main" id="{1BBA5027-6530-2983-00D9-09828FE5947E}"/>
               </a:ext>
             </a:extLst>
           </p:cNvPr>
@@ -3204,7 +3199,7 @@
             </a:lvl1pPr>
           </a:lstStyle>
           <a:p>
-            <a:fld id="{3B04DCD2-51FF-4424-A8D0-554917C1B566}" type="datetimeFigureOut">
+            <a:fld id="{248CC083-DEBD-4D69-8B9A-5124E7F9EAC4}" type="datetimeFigureOut">
               <a:rPr lang="en-US" smtClean="0"/>
               <a:t>5/27/2026</a:t>
             </a:fld>
@@ -3217,7 +3212,7 @@
           <p:cNvPr id="5" name="Footer Placeholder 4">
             <a:extLst>
               <a:ext uri="{FF2B5EF4-FFF2-40B4-BE49-F238E27FC236}">
-                <a16:creationId xmlns:a16="http://schemas.microsoft.com/office/drawing/2014/main" id="{AE765D20-3810-275A-3155-C45B0F37ED10}"/>
+                <a16:creationId xmlns:a16="http://schemas.microsoft.com/office/drawing/2014/main" id="{BD7AF470-85D4-4693-5390-FACB12E7D6AA}"/>
               </a:ext>
             </a:extLst>
           </p:cNvPr>
@@ -3260,7 +3255,7 @@
           <p:cNvPr id="6" name="Slide Number Placeholder 5">
             <a:extLst>
               <a:ext uri="{FF2B5EF4-FFF2-40B4-BE49-F238E27FC236}">
-                <a16:creationId xmlns:a16="http://schemas.microsoft.com/office/drawing/2014/main" id="{A1663C36-0A70-68E0-947E-A23CFBEB1E65}"/>
+                <a16:creationId xmlns:a16="http://schemas.microsoft.com/office/drawing/2014/main" id="{D761327C-B750-C0BA-78DB-C3ED370713B5}"/>
               </a:ext>
             </a:extLst>
           </p:cNvPr>
@@ -3294,7 +3289,7 @@
             </a:lvl1pPr>
           </a:lstStyle>
           <a:p>
-            <a:fld id="{AB36B74C-88B0-43C8-957A-2BB332CCF888}" type="slidenum">
+            <a:fld id="{E9775BDE-1FD4-4F3F-94CA-6D2F775373B6}" type="slidenum">
               <a:rPr lang="en-US" smtClean="0"/>
               <a:t>‹#›</a:t>
             </a:fld>
@@ -3305,7 +3300,7 @@
     </p:spTree>
     <p:extLst>
       <p:ext uri="{BB962C8B-B14F-4D97-AF65-F5344CB8AC3E}">
-        <p14:creationId xmlns:p14="http://schemas.microsoft.com/office/powerpoint/2010/main" val="1532393703"/>
+        <p14:creationId xmlns:p14="http://schemas.microsoft.com/office/powerpoint/2010/main" val="537972616"/>
       </p:ext>
     </p:extLst>
   </p:cSld>
@@ -3628,7 +3623,7 @@
           <p:cNvPr id="2" name="Chart 1">
             <a:extLst>
               <a:ext uri="{FF2B5EF4-FFF2-40B4-BE49-F238E27FC236}">
-                <a16:creationId xmlns:a16="http://schemas.microsoft.com/office/drawing/2014/main" id="{786DCFC8-C050-6522-DF11-71479FC3AEE8}"/>
+                <a16:creationId xmlns:a16="http://schemas.microsoft.com/office/drawing/2014/main" id="{7601DD8D-31E6-60F5-592E-1524EE4EB7E5}"/>
               </a:ext>
             </a:extLst>
           </p:cNvPr>
@@ -3636,14 +3631,14 @@
           <p:nvPr>
             <p:extLst>
               <p:ext uri="{D42A27DB-BD31-4B8C-83A1-F6EECF244321}">
-                <p14:modId xmlns:p14="http://schemas.microsoft.com/office/powerpoint/2010/main" val="2795304778"/>
+                <p14:modId xmlns:p14="http://schemas.microsoft.com/office/powerpoint/2010/main" val="1777573001"/>
               </p:ext>
             </p:extLst>
           </p:nvPr>
         </p:nvGraphicFramePr>
         <p:xfrm>
-          <a:off x="1828800" y="457200"/>
-          <a:ext cx="7315200" cy="5486400"/>
+          <a:off x="1828800" y="762000"/>
+          <a:ext cx="6604000" cy="4572000"/>
         </p:xfrm>
         <a:graphic>
           <a:graphicData uri="http://schemas.openxmlformats.org/drawingml/2006/chart">
@@ -3654,7 +3649,7 @@
     </p:spTree>
     <p:extLst>
       <p:ext uri="{BB962C8B-B14F-4D97-AF65-F5344CB8AC3E}">
-        <p14:creationId xmlns:p14="http://schemas.microsoft.com/office/powerpoint/2010/main" val="1790419625"/>
+        <p14:creationId xmlns:p14="http://schemas.microsoft.com/office/powerpoint/2010/main" val="3702692306"/>
       </p:ext>
     </p:extLst>
   </p:cSld>

</xml_diff>